<commit_message>
Update deck and video track identification
</commit_message>
<xml_diff>
--- a/docs/assets/FormulaBench-Hackathon-Deck.pptx
+++ b/docs/assets/FormulaBench-Hackathon-Deck.pptx
@@ -2,20 +2,20 @@
 <file path=ppt/presentation.xml><?xml version="1.0" encoding="utf-8"?>
 <p:presentation xmlns:p="http://schemas.openxmlformats.org/presentationml/2006/main">
   <p:sldMasterIdLst>
-    <p:sldMasterId xmlns:r="http://schemas.openxmlformats.org/officeDocument/2006/relationships" id="2147483648" r:id="R8801c75695f94f03"/>
+    <p:sldMasterId xmlns:r="http://schemas.openxmlformats.org/officeDocument/2006/relationships" id="2147483648" r:id="R471e2744b4d84d1d"/>
   </p:sldMasterIdLst>
   <p:notesMasterIdLst>
-    <p:notesMasterId xmlns:r="http://schemas.openxmlformats.org/officeDocument/2006/relationships" r:id="R872e820f27594ab4"/>
+    <p:notesMasterId xmlns:r="http://schemas.openxmlformats.org/officeDocument/2006/relationships" r:id="Rd3680a0bd82b4574"/>
   </p:notesMasterIdLst>
   <p:sldIdLst>
-    <p:sldId xmlns:r="http://schemas.openxmlformats.org/officeDocument/2006/relationships" id="256" r:id="Re93ae3687b80495c"/>
-    <p:sldId xmlns:r="http://schemas.openxmlformats.org/officeDocument/2006/relationships" id="257" r:id="R4c6d30c6d22c4f3d"/>
-    <p:sldId xmlns:r="http://schemas.openxmlformats.org/officeDocument/2006/relationships" id="258" r:id="Rf4903c6304be4764"/>
-    <p:sldId xmlns:r="http://schemas.openxmlformats.org/officeDocument/2006/relationships" id="259" r:id="R708608d061ab475b"/>
-    <p:sldId xmlns:r="http://schemas.openxmlformats.org/officeDocument/2006/relationships" id="260" r:id="R21ac3794744a4b9d"/>
-    <p:sldId xmlns:r="http://schemas.openxmlformats.org/officeDocument/2006/relationships" id="261" r:id="Rcc97828a411b4b84"/>
-    <p:sldId xmlns:r="http://schemas.openxmlformats.org/officeDocument/2006/relationships" id="262" r:id="R5343badcf1074f6d"/>
-    <p:sldId xmlns:r="http://schemas.openxmlformats.org/officeDocument/2006/relationships" id="263" r:id="R2b9f722ad50e490b"/>
+    <p:sldId xmlns:r="http://schemas.openxmlformats.org/officeDocument/2006/relationships" id="256" r:id="R447368ac096e453d"/>
+    <p:sldId xmlns:r="http://schemas.openxmlformats.org/officeDocument/2006/relationships" id="257" r:id="Rfa6453711fb544e2"/>
+    <p:sldId xmlns:r="http://schemas.openxmlformats.org/officeDocument/2006/relationships" id="258" r:id="R96502637e6b541a9"/>
+    <p:sldId xmlns:r="http://schemas.openxmlformats.org/officeDocument/2006/relationships" id="259" r:id="R6450c43eeef14111"/>
+    <p:sldId xmlns:r="http://schemas.openxmlformats.org/officeDocument/2006/relationships" id="260" r:id="R64a3ed262a254dde"/>
+    <p:sldId xmlns:r="http://schemas.openxmlformats.org/officeDocument/2006/relationships" id="261" r:id="Rc6fd4c1350994cc4"/>
+    <p:sldId xmlns:r="http://schemas.openxmlformats.org/officeDocument/2006/relationships" id="262" r:id="Rf113d718002e4e6d"/>
+    <p:sldId xmlns:r="http://schemas.openxmlformats.org/officeDocument/2006/relationships" id="263" r:id="Raa89fb6967bb4faf"/>
   </p:sldIdLst>
   <p:sldSz cx="12192000" cy="6858000"/>
   <p:notesSz cx="6858000" cy="9144000"/>
@@ -1202,7 +1202,7 @@
   </p:cSld>
   <p:clrMap bg1="lt1" tx1="dk1" bg2="lt2" tx2="dk2" accent1="accent1" accent2="accent2" accent3="accent3" accent4="accent4" accent5="accent5" accent6="accent6" hlink="hlink" folHlink="folHlink"/>
   <p:sldLayoutIdLst>
-    <p:sldLayoutId xmlns:r="http://schemas.openxmlformats.org/officeDocument/2006/relationships" id="2147483649" r:id="R21524589e09e4f6b"/>
+    <p:sldLayoutId xmlns:r="http://schemas.openxmlformats.org/officeDocument/2006/relationships" id="2147483649" r:id="Re9f51bc1e1e24617"/>
   </p:sldLayoutIdLst>
   <p:txStyles>
     <p:titleStyle>
@@ -2046,7 +2046,7 @@
           <p:cNvPr id="9" name="">
             <a:extLst xmlns:a="http://schemas.openxmlformats.org/drawingml/2006/main">
               <a:ext uri="{FF2B5EF4-FFF2-40B4-BE49-F238E27FC236}">
-                <a16:creationId xmlns:a16="http://schemas.microsoft.com/office/drawing/2014/main" id="{50C10181-1F51-4B1E-8C46-05502D297C1A}"/>
+                <a16:creationId xmlns:a16="http://schemas.microsoft.com/office/drawing/2014/main" id="{D39C05EF-3558-418F-961F-CCBDB1DB0094}"/>
               </a:ext>
             </a:extLst>
           </p:cNvPr>
@@ -2107,7 +2107,7 @@
           <p:cNvPr id="2" name="">
             <a:extLst xmlns:a="http://schemas.openxmlformats.org/drawingml/2006/main">
               <a:ext uri="{FF2B5EF4-FFF2-40B4-BE49-F238E27FC236}">
-                <a16:creationId xmlns:a16="http://schemas.microsoft.com/office/drawing/2014/main" id="{76F0A433-1B5F-40C0-A848-711343C4D3F5}"/>
+                <a16:creationId xmlns:a16="http://schemas.microsoft.com/office/drawing/2014/main" id="{5D684BFA-5DF8-4287-9353-CDB24724AA24}"/>
               </a:ext>
             </a:extLst>
           </p:cNvPr>
@@ -2168,7 +2168,7 @@
           <p:cNvPr id="3" name="">
             <a:extLst xmlns:a="http://schemas.openxmlformats.org/drawingml/2006/main">
               <a:ext uri="{FF2B5EF4-FFF2-40B4-BE49-F238E27FC236}">
-                <a16:creationId xmlns:a16="http://schemas.microsoft.com/office/drawing/2014/main" id="{431C5799-0BF4-427A-A11B-A2C30EE900C3}"/>
+                <a16:creationId xmlns:a16="http://schemas.microsoft.com/office/drawing/2014/main" id="{B1407B73-C460-4479-B307-142C5C4C6943}"/>
               </a:ext>
             </a:extLst>
           </p:cNvPr>
@@ -2229,7 +2229,7 @@
           <p:cNvPr id="4" name="">
             <a:extLst xmlns:a="http://schemas.openxmlformats.org/drawingml/2006/main">
               <a:ext uri="{FF2B5EF4-FFF2-40B4-BE49-F238E27FC236}">
-                <a16:creationId xmlns:a16="http://schemas.microsoft.com/office/drawing/2014/main" id="{91326E6C-B848-4446-AEE1-AF8CBE39B845}"/>
+                <a16:creationId xmlns:a16="http://schemas.microsoft.com/office/drawing/2014/main" id="{82734427-D76A-47EE-BC66-2E48B2F2B7AB}"/>
               </a:ext>
             </a:extLst>
           </p:cNvPr>
@@ -2260,7 +2260,7 @@
           <p:cNvPr id="5" name="">
             <a:extLst xmlns:a="http://schemas.openxmlformats.org/drawingml/2006/main">
               <a:ext uri="{FF2B5EF4-FFF2-40B4-BE49-F238E27FC236}">
-                <a16:creationId xmlns:a16="http://schemas.microsoft.com/office/drawing/2014/main" id="{CC3FBA75-89A2-406C-9B56-1E0B88735BC7}"/>
+                <a16:creationId xmlns:a16="http://schemas.microsoft.com/office/drawing/2014/main" id="{2F62FF7D-6CE4-4A2B-A7F1-399EFCBBDCD4}"/>
               </a:ext>
             </a:extLst>
           </p:cNvPr>
@@ -2311,7 +2311,7 @@
                 <a:ea typeface="Arial"/>
                 <a:cs typeface="Arial"/>
               </a:rPr>
-              <a:t>Research / Track 2</a:t>
+              <a:t>Research: Excel Formula Generation</a:t>
             </a:r>
           </a:p>
           <a:p xmlns:a="http://schemas.openxmlformats.org/drawingml/2006/main">
@@ -2348,7 +2348,7 @@
           <p:cNvPr id="6" name="">
             <a:extLst xmlns:a="http://schemas.openxmlformats.org/drawingml/2006/main">
               <a:ext uri="{FF2B5EF4-FFF2-40B4-BE49-F238E27FC236}">
-                <a16:creationId xmlns:a16="http://schemas.microsoft.com/office/drawing/2014/main" id="{330907F1-1244-47A9-86A9-D0BCC5592C88}"/>
+                <a16:creationId xmlns:a16="http://schemas.microsoft.com/office/drawing/2014/main" id="{6BB6B4BC-AF62-4DC0-A044-5205F39B589A}"/>
               </a:ext>
             </a:extLst>
           </p:cNvPr>
@@ -2517,7 +2517,7 @@
           <p:cNvPr id="7" name="">
             <a:extLst xmlns:a="http://schemas.openxmlformats.org/drawingml/2006/main">
               <a:ext uri="{FF2B5EF4-FFF2-40B4-BE49-F238E27FC236}">
-                <a16:creationId xmlns:a16="http://schemas.microsoft.com/office/drawing/2014/main" id="{F4088BC7-59A6-4E37-9AB3-2AE90CF8D688}"/>
+                <a16:creationId xmlns:a16="http://schemas.microsoft.com/office/drawing/2014/main" id="{74C44928-222D-4242-B52B-A15A3A02C839}"/>
               </a:ext>
             </a:extLst>
           </p:cNvPr>
@@ -2578,7 +2578,7 @@
           <p:cNvPr id="8" name="">
             <a:extLst xmlns:a="http://schemas.openxmlformats.org/drawingml/2006/main">
               <a:ext uri="{FF2B5EF4-FFF2-40B4-BE49-F238E27FC236}">
-                <a16:creationId xmlns:a16="http://schemas.microsoft.com/office/drawing/2014/main" id="{82617AB2-2FFF-4924-A0D3-C325E4FD293E}"/>
+                <a16:creationId xmlns:a16="http://schemas.microsoft.com/office/drawing/2014/main" id="{A317AD4D-4BF1-48E5-9F80-70485077EB32}"/>
               </a:ext>
             </a:extLst>
           </p:cNvPr>
@@ -2637,7 +2637,7 @@
     </p:spTree>
     <p:extLst>
       <p:ext uri="{BB962C8B-B14F-4D97-AF65-F5344CB8AC3E}">
-        <p14:creationId xmlns:p14="http://schemas.microsoft.com/office/powerpoint/2010/main" val="585923939"/>
+        <p14:creationId xmlns:p14="http://schemas.microsoft.com/office/powerpoint/2010/main" val="1282237158"/>
       </p:ext>
     </p:extLst>
   </p:cSld>
@@ -2668,7 +2668,7 @@
           <p:cNvPr id="14" name="slide-title">
             <a:extLst xmlns:a="http://schemas.openxmlformats.org/drawingml/2006/main">
               <a:ext uri="{FF2B5EF4-FFF2-40B4-BE49-F238E27FC236}">
-                <a16:creationId xmlns:a16="http://schemas.microsoft.com/office/drawing/2014/main" id="{885EC345-FAA5-4F68-88ED-A6C32EFAF0B6}"/>
+                <a16:creationId xmlns:a16="http://schemas.microsoft.com/office/drawing/2014/main" id="{C332DD45-E2B0-4B59-81B5-A2AD48DD0DAE}"/>
               </a:ext>
             </a:extLst>
           </p:cNvPr>
@@ -2729,7 +2729,7 @@
           <p:cNvPr id="2" name="">
             <a:extLst xmlns:a="http://schemas.openxmlformats.org/drawingml/2006/main">
               <a:ext uri="{FF2B5EF4-FFF2-40B4-BE49-F238E27FC236}">
-                <a16:creationId xmlns:a16="http://schemas.microsoft.com/office/drawing/2014/main" id="{EEEE5744-0295-462D-88A0-C3E92D931C41}"/>
+                <a16:creationId xmlns:a16="http://schemas.microsoft.com/office/drawing/2014/main" id="{B3A6B431-0514-4C88-BFB2-F1400C9436BA}"/>
               </a:ext>
             </a:extLst>
           </p:cNvPr>
@@ -2790,7 +2790,7 @@
           <p:cNvPr id="3" name="">
             <a:extLst xmlns:a="http://schemas.openxmlformats.org/drawingml/2006/main">
               <a:ext uri="{FF2B5EF4-FFF2-40B4-BE49-F238E27FC236}">
-                <a16:creationId xmlns:a16="http://schemas.microsoft.com/office/drawing/2014/main" id="{A5666C6F-B306-447F-A4D3-76DDF8322942}"/>
+                <a16:creationId xmlns:a16="http://schemas.microsoft.com/office/drawing/2014/main" id="{1D1514B2-C9B9-46CC-A57F-4960CE74B1D4}"/>
               </a:ext>
             </a:extLst>
           </p:cNvPr>
@@ -2851,7 +2851,7 @@
           <p:cNvPr id="4" name="">
             <a:extLst xmlns:a="http://schemas.openxmlformats.org/drawingml/2006/main">
               <a:ext uri="{FF2B5EF4-FFF2-40B4-BE49-F238E27FC236}">
-                <a16:creationId xmlns:a16="http://schemas.microsoft.com/office/drawing/2014/main" id="{29972A5B-D5E9-4396-BBA4-3F2E751F452B}"/>
+                <a16:creationId xmlns:a16="http://schemas.microsoft.com/office/drawing/2014/main" id="{F3C357DA-FE73-4B1A-9325-CEC7AF5BDA72}"/>
               </a:ext>
             </a:extLst>
           </p:cNvPr>
@@ -2912,7 +2912,7 @@
           <p:cNvPr id="5" name="">
             <a:extLst xmlns:a="http://schemas.openxmlformats.org/drawingml/2006/main">
               <a:ext uri="{FF2B5EF4-FFF2-40B4-BE49-F238E27FC236}">
-                <a16:creationId xmlns:a16="http://schemas.microsoft.com/office/drawing/2014/main" id="{0F751ACC-F284-470C-A7BB-585EB10F16C1}"/>
+                <a16:creationId xmlns:a16="http://schemas.microsoft.com/office/drawing/2014/main" id="{6621569C-42E7-4334-B269-E0F136F68BCD}"/>
               </a:ext>
             </a:extLst>
           </p:cNvPr>
@@ -2973,7 +2973,7 @@
           <p:cNvPr id="6" name="">
             <a:extLst xmlns:a="http://schemas.openxmlformats.org/drawingml/2006/main">
               <a:ext uri="{FF2B5EF4-FFF2-40B4-BE49-F238E27FC236}">
-                <a16:creationId xmlns:a16="http://schemas.microsoft.com/office/drawing/2014/main" id="{0CB017B7-6EE4-4FCD-87D9-C4E2D291B440}"/>
+                <a16:creationId xmlns:a16="http://schemas.microsoft.com/office/drawing/2014/main" id="{967ACCBF-8B54-453F-8DB8-F673738400EF}"/>
               </a:ext>
             </a:extLst>
           </p:cNvPr>
@@ -3034,7 +3034,7 @@
           <p:cNvPr id="7" name="">
             <a:extLst xmlns:a="http://schemas.openxmlformats.org/drawingml/2006/main">
               <a:ext uri="{FF2B5EF4-FFF2-40B4-BE49-F238E27FC236}">
-                <a16:creationId xmlns:a16="http://schemas.microsoft.com/office/drawing/2014/main" id="{5C431A68-50B6-4630-B630-057B86E38B14}"/>
+                <a16:creationId xmlns:a16="http://schemas.microsoft.com/office/drawing/2014/main" id="{76707E3F-92B4-48FB-A23B-662F67536CC3}"/>
               </a:ext>
             </a:extLst>
           </p:cNvPr>
@@ -3095,7 +3095,7 @@
           <p:cNvPr id="8" name="">
             <a:extLst xmlns:a="http://schemas.openxmlformats.org/drawingml/2006/main">
               <a:ext uri="{FF2B5EF4-FFF2-40B4-BE49-F238E27FC236}">
-                <a16:creationId xmlns:a16="http://schemas.microsoft.com/office/drawing/2014/main" id="{CDFBDA0D-8441-4BF5-9706-237FF25B5CBB}"/>
+                <a16:creationId xmlns:a16="http://schemas.microsoft.com/office/drawing/2014/main" id="{6F118762-3DA0-409F-83FF-0C01F13E0C66}"/>
               </a:ext>
             </a:extLst>
           </p:cNvPr>
@@ -3163,7 +3163,7 @@
         </p:xfrm>
         <a:graphic xmlns:a="http://schemas.openxmlformats.org/drawingml/2006/main">
           <a:graphicData uri="http://schemas.openxmlformats.org/drawingml/2006/chart">
-            <c:chart xmlns:r="http://schemas.openxmlformats.org/officeDocument/2006/relationships" xmlns:c="http://schemas.openxmlformats.org/drawingml/2006/chart" r:id="Rb31b5b8cc256491a"/>
+            <c:chart xmlns:r="http://schemas.openxmlformats.org/officeDocument/2006/relationships" xmlns:c="http://schemas.openxmlformats.org/drawingml/2006/chart" r:id="Ra3592e46faba462c"/>
           </a:graphicData>
         </a:graphic>
       </p:graphicFrame>
@@ -3172,7 +3172,7 @@
           <p:cNvPr id="10" name="">
             <a:extLst xmlns:a="http://schemas.openxmlformats.org/drawingml/2006/main">
               <a:ext uri="{FF2B5EF4-FFF2-40B4-BE49-F238E27FC236}">
-                <a16:creationId xmlns:a16="http://schemas.microsoft.com/office/drawing/2014/main" id="{9CE24B08-A9A7-4A6A-8727-60CD41D95D17}"/>
+                <a16:creationId xmlns:a16="http://schemas.microsoft.com/office/drawing/2014/main" id="{A9D35BEA-EAB5-42C7-94D3-AC9868F43BF6}"/>
               </a:ext>
             </a:extLst>
           </p:cNvPr>
@@ -3233,7 +3233,7 @@
           <p:cNvPr id="11" name="">
             <a:extLst xmlns:a="http://schemas.openxmlformats.org/drawingml/2006/main">
               <a:ext uri="{FF2B5EF4-FFF2-40B4-BE49-F238E27FC236}">
-                <a16:creationId xmlns:a16="http://schemas.microsoft.com/office/drawing/2014/main" id="{E38B42F7-6295-44B9-BE82-E9F2FC3BB36B}"/>
+                <a16:creationId xmlns:a16="http://schemas.microsoft.com/office/drawing/2014/main" id="{BAD4151B-AE70-4183-8EE9-0D11640FCBC5}"/>
               </a:ext>
             </a:extLst>
           </p:cNvPr>
@@ -3264,7 +3264,7 @@
           <p:cNvPr id="12" name="">
             <a:extLst xmlns:a="http://schemas.openxmlformats.org/drawingml/2006/main">
               <a:ext uri="{FF2B5EF4-FFF2-40B4-BE49-F238E27FC236}">
-                <a16:creationId xmlns:a16="http://schemas.microsoft.com/office/drawing/2014/main" id="{5874FED2-31A8-4653-A8E9-E5F49D60929D}"/>
+                <a16:creationId xmlns:a16="http://schemas.microsoft.com/office/drawing/2014/main" id="{7F14F7A6-5D50-44E3-81C0-5CC9B756A717}"/>
               </a:ext>
             </a:extLst>
           </p:cNvPr>
@@ -3315,7 +3315,7 @@
                 <a:ea typeface="Arial"/>
                 <a:cs typeface="Arial"/>
               </a:rPr>
-              <a:t>FORMULABENCH  ·  RESEARCH / TRACK 2</a:t>
+              <a:t>FORMULABENCH  ·  RESEARCH: EXCEL FORMULA GENERATION</a:t>
             </a:r>
           </a:p>
         </p:txBody>
@@ -3325,7 +3325,7 @@
           <p:cNvPr id="13" name="">
             <a:extLst xmlns:a="http://schemas.openxmlformats.org/drawingml/2006/main">
               <a:ext uri="{FF2B5EF4-FFF2-40B4-BE49-F238E27FC236}">
-                <a16:creationId xmlns:a16="http://schemas.microsoft.com/office/drawing/2014/main" id="{C18598F6-A6CD-4D79-828D-FBF48D9C9405}"/>
+                <a16:creationId xmlns:a16="http://schemas.microsoft.com/office/drawing/2014/main" id="{B06E1ED5-C5E5-4E6E-A9C3-9345293CC8C7}"/>
               </a:ext>
             </a:extLst>
           </p:cNvPr>
@@ -3384,7 +3384,7 @@
     </p:spTree>
     <p:extLst>
       <p:ext uri="{BB962C8B-B14F-4D97-AF65-F5344CB8AC3E}">
-        <p14:creationId xmlns:p14="http://schemas.microsoft.com/office/powerpoint/2010/main" val="327622992"/>
+        <p14:creationId xmlns:p14="http://schemas.microsoft.com/office/powerpoint/2010/main" val="1836066887"/>
       </p:ext>
     </p:extLst>
   </p:cSld>
@@ -3415,7 +3415,7 @@
           <p:cNvPr id="23" name="slide-title">
             <a:extLst xmlns:a="http://schemas.openxmlformats.org/drawingml/2006/main">
               <a:ext uri="{FF2B5EF4-FFF2-40B4-BE49-F238E27FC236}">
-                <a16:creationId xmlns:a16="http://schemas.microsoft.com/office/drawing/2014/main" id="{87D1FAE9-4A47-4688-9FB4-3817074D5BCA}"/>
+                <a16:creationId xmlns:a16="http://schemas.microsoft.com/office/drawing/2014/main" id="{97CA310F-D86A-49B1-89BF-9ACC6236BDAD}"/>
               </a:ext>
             </a:extLst>
           </p:cNvPr>
@@ -3476,7 +3476,7 @@
           <p:cNvPr id="2" name="">
             <a:extLst xmlns:a="http://schemas.openxmlformats.org/drawingml/2006/main">
               <a:ext uri="{FF2B5EF4-FFF2-40B4-BE49-F238E27FC236}">
-                <a16:creationId xmlns:a16="http://schemas.microsoft.com/office/drawing/2014/main" id="{3126D8D7-E60B-46A1-B281-6ECD380DBFC8}"/>
+                <a16:creationId xmlns:a16="http://schemas.microsoft.com/office/drawing/2014/main" id="{AF4C521C-D7B9-4C11-BD5B-BA691C346EEA}"/>
               </a:ext>
             </a:extLst>
           </p:cNvPr>
@@ -3537,7 +3537,7 @@
           <p:cNvPr id="3" name="">
             <a:extLst xmlns:a="http://schemas.openxmlformats.org/drawingml/2006/main">
               <a:ext uri="{FF2B5EF4-FFF2-40B4-BE49-F238E27FC236}">
-                <a16:creationId xmlns:a16="http://schemas.microsoft.com/office/drawing/2014/main" id="{42C4AB0F-DC93-4BD6-AB20-3819992659C8}"/>
+                <a16:creationId xmlns:a16="http://schemas.microsoft.com/office/drawing/2014/main" id="{E5D85DE6-C57D-4AFC-ADE3-210DC1B150B1}"/>
               </a:ext>
             </a:extLst>
           </p:cNvPr>
@@ -3598,7 +3598,7 @@
           <p:cNvPr id="4" name="">
             <a:extLst xmlns:a="http://schemas.openxmlformats.org/drawingml/2006/main">
               <a:ext uri="{FF2B5EF4-FFF2-40B4-BE49-F238E27FC236}">
-                <a16:creationId xmlns:a16="http://schemas.microsoft.com/office/drawing/2014/main" id="{DFC8F002-4E40-44DA-8575-F76EFE000A70}"/>
+                <a16:creationId xmlns:a16="http://schemas.microsoft.com/office/drawing/2014/main" id="{3C123DEB-300C-4DE7-8AF2-30B3FFB564DF}"/>
               </a:ext>
             </a:extLst>
           </p:cNvPr>
@@ -3659,7 +3659,7 @@
           <p:cNvPr id="5" name="">
             <a:extLst xmlns:a="http://schemas.openxmlformats.org/drawingml/2006/main">
               <a:ext uri="{FF2B5EF4-FFF2-40B4-BE49-F238E27FC236}">
-                <a16:creationId xmlns:a16="http://schemas.microsoft.com/office/drawing/2014/main" id="{7E3BAFB4-F6F8-4602-8356-1226B86EE861}"/>
+                <a16:creationId xmlns:a16="http://schemas.microsoft.com/office/drawing/2014/main" id="{572B070C-DD95-4DA6-B3D3-6D1A8E576143}"/>
               </a:ext>
             </a:extLst>
           </p:cNvPr>
@@ -3720,7 +3720,7 @@
           <p:cNvPr id="6" name="">
             <a:extLst xmlns:a="http://schemas.openxmlformats.org/drawingml/2006/main">
               <a:ext uri="{FF2B5EF4-FFF2-40B4-BE49-F238E27FC236}">
-                <a16:creationId xmlns:a16="http://schemas.microsoft.com/office/drawing/2014/main" id="{90F2CBF9-21D5-4636-A4CF-46F5A121D25C}"/>
+                <a16:creationId xmlns:a16="http://schemas.microsoft.com/office/drawing/2014/main" id="{7A77A824-6A1A-45A8-9F26-34C7BEF0EAC5}"/>
               </a:ext>
             </a:extLst>
           </p:cNvPr>
@@ -3751,7 +3751,7 @@
           <p:cNvPr id="7" name="">
             <a:extLst xmlns:a="http://schemas.openxmlformats.org/drawingml/2006/main">
               <a:ext uri="{FF2B5EF4-FFF2-40B4-BE49-F238E27FC236}">
-                <a16:creationId xmlns:a16="http://schemas.microsoft.com/office/drawing/2014/main" id="{C6849A79-699D-40F8-BC13-369B2020AEFC}"/>
+                <a16:creationId xmlns:a16="http://schemas.microsoft.com/office/drawing/2014/main" id="{CDFDDAB6-A8CF-4ED6-B995-CE42ED65D913}"/>
               </a:ext>
             </a:extLst>
           </p:cNvPr>
@@ -3812,7 +3812,7 @@
           <p:cNvPr id="8" name="">
             <a:extLst xmlns:a="http://schemas.openxmlformats.org/drawingml/2006/main">
               <a:ext uri="{FF2B5EF4-FFF2-40B4-BE49-F238E27FC236}">
-                <a16:creationId xmlns:a16="http://schemas.microsoft.com/office/drawing/2014/main" id="{717B12E9-A573-46A6-A86F-6ED4652473FF}"/>
+                <a16:creationId xmlns:a16="http://schemas.microsoft.com/office/drawing/2014/main" id="{74111B4A-8A88-4577-A93F-7DFA6EFA79CB}"/>
               </a:ext>
             </a:extLst>
           </p:cNvPr>
@@ -3873,7 +3873,7 @@
           <p:cNvPr id="9" name="">
             <a:extLst xmlns:a="http://schemas.openxmlformats.org/drawingml/2006/main">
               <a:ext uri="{FF2B5EF4-FFF2-40B4-BE49-F238E27FC236}">
-                <a16:creationId xmlns:a16="http://schemas.microsoft.com/office/drawing/2014/main" id="{B519ED67-516C-4B5C-922D-2ABCB0D0848E}"/>
+                <a16:creationId xmlns:a16="http://schemas.microsoft.com/office/drawing/2014/main" id="{95B92058-C0B7-4DAA-88ED-4BAF7D71BC73}"/>
               </a:ext>
             </a:extLst>
           </p:cNvPr>
@@ -3934,7 +3934,7 @@
           <p:cNvPr id="10" name="">
             <a:extLst xmlns:a="http://schemas.openxmlformats.org/drawingml/2006/main">
               <a:ext uri="{FF2B5EF4-FFF2-40B4-BE49-F238E27FC236}">
-                <a16:creationId xmlns:a16="http://schemas.microsoft.com/office/drawing/2014/main" id="{5D3AD0D4-FF25-4FEB-AE0B-2D3A4B79601A}"/>
+                <a16:creationId xmlns:a16="http://schemas.microsoft.com/office/drawing/2014/main" id="{A8FC0EF1-FD3D-4E89-AC6B-0A06797599DE}"/>
               </a:ext>
             </a:extLst>
           </p:cNvPr>
@@ -3965,7 +3965,7 @@
           <p:cNvPr id="11" name="">
             <a:extLst xmlns:a="http://schemas.openxmlformats.org/drawingml/2006/main">
               <a:ext uri="{FF2B5EF4-FFF2-40B4-BE49-F238E27FC236}">
-                <a16:creationId xmlns:a16="http://schemas.microsoft.com/office/drawing/2014/main" id="{AB29D075-DC6E-495D-88B6-04C7852AD2C5}"/>
+                <a16:creationId xmlns:a16="http://schemas.microsoft.com/office/drawing/2014/main" id="{0932F782-722C-4DC3-A6F1-4F6FAF6FAC50}"/>
               </a:ext>
             </a:extLst>
           </p:cNvPr>
@@ -4026,7 +4026,7 @@
           <p:cNvPr id="12" name="">
             <a:extLst xmlns:a="http://schemas.openxmlformats.org/drawingml/2006/main">
               <a:ext uri="{FF2B5EF4-FFF2-40B4-BE49-F238E27FC236}">
-                <a16:creationId xmlns:a16="http://schemas.microsoft.com/office/drawing/2014/main" id="{72B6B510-0088-4CA2-993B-1B5A8CD9E100}"/>
+                <a16:creationId xmlns:a16="http://schemas.microsoft.com/office/drawing/2014/main" id="{BDB391CF-D829-4AD9-8C1E-F650630D3FEE}"/>
               </a:ext>
             </a:extLst>
           </p:cNvPr>
@@ -4087,7 +4087,7 @@
           <p:cNvPr id="13" name="">
             <a:extLst xmlns:a="http://schemas.openxmlformats.org/drawingml/2006/main">
               <a:ext uri="{FF2B5EF4-FFF2-40B4-BE49-F238E27FC236}">
-                <a16:creationId xmlns:a16="http://schemas.microsoft.com/office/drawing/2014/main" id="{9525448F-083A-4329-B387-F75F5CBA1194}"/>
+                <a16:creationId xmlns:a16="http://schemas.microsoft.com/office/drawing/2014/main" id="{A5A28442-1A48-4B15-B249-77051951F192}"/>
               </a:ext>
             </a:extLst>
           </p:cNvPr>
@@ -4148,7 +4148,7 @@
           <p:cNvPr id="14" name="">
             <a:extLst xmlns:a="http://schemas.openxmlformats.org/drawingml/2006/main">
               <a:ext uri="{FF2B5EF4-FFF2-40B4-BE49-F238E27FC236}">
-                <a16:creationId xmlns:a16="http://schemas.microsoft.com/office/drawing/2014/main" id="{6A0B43C5-1454-495D-B285-A8E14F313CA5}"/>
+                <a16:creationId xmlns:a16="http://schemas.microsoft.com/office/drawing/2014/main" id="{4ADF4A8C-E2DE-4D3C-A54C-2A5E00C40974}"/>
               </a:ext>
             </a:extLst>
           </p:cNvPr>
@@ -4179,7 +4179,7 @@
           <p:cNvPr id="15" name="">
             <a:extLst xmlns:a="http://schemas.openxmlformats.org/drawingml/2006/main">
               <a:ext uri="{FF2B5EF4-FFF2-40B4-BE49-F238E27FC236}">
-                <a16:creationId xmlns:a16="http://schemas.microsoft.com/office/drawing/2014/main" id="{B24F811E-C234-437C-A37E-72AF6A536AA6}"/>
+                <a16:creationId xmlns:a16="http://schemas.microsoft.com/office/drawing/2014/main" id="{0867A4B3-B502-43DA-AF49-625E390EE3B5}"/>
               </a:ext>
             </a:extLst>
           </p:cNvPr>
@@ -4240,7 +4240,7 @@
           <p:cNvPr id="16" name="">
             <a:extLst xmlns:a="http://schemas.openxmlformats.org/drawingml/2006/main">
               <a:ext uri="{FF2B5EF4-FFF2-40B4-BE49-F238E27FC236}">
-                <a16:creationId xmlns:a16="http://schemas.microsoft.com/office/drawing/2014/main" id="{52DE63ED-BF53-4AB9-9D0B-E6A4BC992080}"/>
+                <a16:creationId xmlns:a16="http://schemas.microsoft.com/office/drawing/2014/main" id="{6B58B03C-40EF-4C1B-86D9-5989E4BF43B1}"/>
               </a:ext>
             </a:extLst>
           </p:cNvPr>
@@ -4301,7 +4301,7 @@
           <p:cNvPr id="17" name="">
             <a:extLst xmlns:a="http://schemas.openxmlformats.org/drawingml/2006/main">
               <a:ext uri="{FF2B5EF4-FFF2-40B4-BE49-F238E27FC236}">
-                <a16:creationId xmlns:a16="http://schemas.microsoft.com/office/drawing/2014/main" id="{CD098F07-9CF1-43F9-AFEB-F3E0B5C2D89E}"/>
+                <a16:creationId xmlns:a16="http://schemas.microsoft.com/office/drawing/2014/main" id="{3385CD1C-64A4-4CA7-BBB6-C9A8ACF98CF5}"/>
               </a:ext>
             </a:extLst>
           </p:cNvPr>
@@ -4362,7 +4362,7 @@
           <p:cNvPr id="18" name="">
             <a:extLst xmlns:a="http://schemas.openxmlformats.org/drawingml/2006/main">
               <a:ext uri="{FF2B5EF4-FFF2-40B4-BE49-F238E27FC236}">
-                <a16:creationId xmlns:a16="http://schemas.microsoft.com/office/drawing/2014/main" id="{61C8B737-DF6B-4498-9085-836EB9BE5210}"/>
+                <a16:creationId xmlns:a16="http://schemas.microsoft.com/office/drawing/2014/main" id="{33C08DA3-6ED6-435F-A416-53752EA30479}"/>
               </a:ext>
             </a:extLst>
           </p:cNvPr>
@@ -4392,7 +4392,7 @@
           <p:cNvPr id="19" name="">
             <a:extLst xmlns:a="http://schemas.openxmlformats.org/drawingml/2006/main">
               <a:ext uri="{FF2B5EF4-FFF2-40B4-BE49-F238E27FC236}">
-                <a16:creationId xmlns:a16="http://schemas.microsoft.com/office/drawing/2014/main" id="{CD6EE083-AF59-47F1-8F9E-CF93EC33ED10}"/>
+                <a16:creationId xmlns:a16="http://schemas.microsoft.com/office/drawing/2014/main" id="{CB03DD9F-261A-4AC0-8718-6A20A481F41B}"/>
               </a:ext>
             </a:extLst>
           </p:cNvPr>
@@ -4453,7 +4453,7 @@
           <p:cNvPr id="20" name="">
             <a:extLst xmlns:a="http://schemas.openxmlformats.org/drawingml/2006/main">
               <a:ext uri="{FF2B5EF4-FFF2-40B4-BE49-F238E27FC236}">
-                <a16:creationId xmlns:a16="http://schemas.microsoft.com/office/drawing/2014/main" id="{5A3F0D77-BEA1-48C6-89B8-F26F8C89B942}"/>
+                <a16:creationId xmlns:a16="http://schemas.microsoft.com/office/drawing/2014/main" id="{C5E2D4CF-CD78-4ED6-95B9-505070F9FF20}"/>
               </a:ext>
             </a:extLst>
           </p:cNvPr>
@@ -4484,7 +4484,7 @@
           <p:cNvPr id="21" name="">
             <a:extLst xmlns:a="http://schemas.openxmlformats.org/drawingml/2006/main">
               <a:ext uri="{FF2B5EF4-FFF2-40B4-BE49-F238E27FC236}">
-                <a16:creationId xmlns:a16="http://schemas.microsoft.com/office/drawing/2014/main" id="{F00AAA7D-C612-474D-AE41-87EC44D2B2F4}"/>
+                <a16:creationId xmlns:a16="http://schemas.microsoft.com/office/drawing/2014/main" id="{A9540AF3-BBF2-492B-A52E-A470D37111FC}"/>
               </a:ext>
             </a:extLst>
           </p:cNvPr>
@@ -4535,7 +4535,7 @@
                 <a:ea typeface="Arial"/>
                 <a:cs typeface="Arial"/>
               </a:rPr>
-              <a:t>FORMULABENCH  ·  RESEARCH / TRACK 2</a:t>
+              <a:t>FORMULABENCH  ·  RESEARCH: EXCEL FORMULA GENERATION</a:t>
             </a:r>
           </a:p>
         </p:txBody>
@@ -4545,7 +4545,7 @@
           <p:cNvPr id="22" name="">
             <a:extLst xmlns:a="http://schemas.openxmlformats.org/drawingml/2006/main">
               <a:ext uri="{FF2B5EF4-FFF2-40B4-BE49-F238E27FC236}">
-                <a16:creationId xmlns:a16="http://schemas.microsoft.com/office/drawing/2014/main" id="{9FF06154-D016-4BA6-88F5-C20A6B72766A}"/>
+                <a16:creationId xmlns:a16="http://schemas.microsoft.com/office/drawing/2014/main" id="{D835E5E5-6136-4CF1-AC2E-12D97193DA36}"/>
               </a:ext>
             </a:extLst>
           </p:cNvPr>
@@ -4604,7 +4604,7 @@
     </p:spTree>
     <p:extLst>
       <p:ext uri="{BB962C8B-B14F-4D97-AF65-F5344CB8AC3E}">
-        <p14:creationId xmlns:p14="http://schemas.microsoft.com/office/powerpoint/2010/main" val="1186433775"/>
+        <p14:creationId xmlns:p14="http://schemas.microsoft.com/office/powerpoint/2010/main" val="693287952"/>
       </p:ext>
     </p:extLst>
   </p:cSld>
@@ -4635,7 +4635,7 @@
           <p:cNvPr id="38" name="slide-title">
             <a:extLst xmlns:a="http://schemas.openxmlformats.org/drawingml/2006/main">
               <a:ext uri="{FF2B5EF4-FFF2-40B4-BE49-F238E27FC236}">
-                <a16:creationId xmlns:a16="http://schemas.microsoft.com/office/drawing/2014/main" id="{A7314E9E-D8C4-4AC4-BF16-ADB16F73827F}"/>
+                <a16:creationId xmlns:a16="http://schemas.microsoft.com/office/drawing/2014/main" id="{36D48C19-F651-434A-9ACA-DE3398088E3D}"/>
               </a:ext>
             </a:extLst>
           </p:cNvPr>
@@ -4696,7 +4696,7 @@
           <p:cNvPr id="2" name="">
             <a:extLst xmlns:a="http://schemas.openxmlformats.org/drawingml/2006/main">
               <a:ext uri="{FF2B5EF4-FFF2-40B4-BE49-F238E27FC236}">
-                <a16:creationId xmlns:a16="http://schemas.microsoft.com/office/drawing/2014/main" id="{C9446748-08D8-4A03-8133-D7736F905BC3}"/>
+                <a16:creationId xmlns:a16="http://schemas.microsoft.com/office/drawing/2014/main" id="{A75B172D-06CF-4C11-A5EC-C324DDB3CEA6}"/>
               </a:ext>
             </a:extLst>
           </p:cNvPr>
@@ -4757,7 +4757,7 @@
           <p:cNvPr id="3" name="">
             <a:extLst xmlns:a="http://schemas.openxmlformats.org/drawingml/2006/main">
               <a:ext uri="{FF2B5EF4-FFF2-40B4-BE49-F238E27FC236}">
-                <a16:creationId xmlns:a16="http://schemas.microsoft.com/office/drawing/2014/main" id="{955F756F-D72E-4224-B0F7-77683A574E5E}"/>
+                <a16:creationId xmlns:a16="http://schemas.microsoft.com/office/drawing/2014/main" id="{4C0F782E-2A74-4E90-945C-786A4A957DBF}"/>
               </a:ext>
             </a:extLst>
           </p:cNvPr>
@@ -4818,7 +4818,7 @@
           <p:cNvPr id="4" name="">
             <a:extLst xmlns:a="http://schemas.openxmlformats.org/drawingml/2006/main">
               <a:ext uri="{FF2B5EF4-FFF2-40B4-BE49-F238E27FC236}">
-                <a16:creationId xmlns:a16="http://schemas.microsoft.com/office/drawing/2014/main" id="{19261769-E965-4807-BE0A-D2E80001285A}"/>
+                <a16:creationId xmlns:a16="http://schemas.microsoft.com/office/drawing/2014/main" id="{29CD9124-735D-4D4B-B614-2CD9015D3DE3}"/>
               </a:ext>
             </a:extLst>
           </p:cNvPr>
@@ -4849,7 +4849,7 @@
           <p:cNvPr id="5" name="">
             <a:extLst xmlns:a="http://schemas.openxmlformats.org/drawingml/2006/main">
               <a:ext uri="{FF2B5EF4-FFF2-40B4-BE49-F238E27FC236}">
-                <a16:creationId xmlns:a16="http://schemas.microsoft.com/office/drawing/2014/main" id="{1B52BBE9-C174-4FF2-8C35-5B94E5C7CC36}"/>
+                <a16:creationId xmlns:a16="http://schemas.microsoft.com/office/drawing/2014/main" id="{1939C090-CCB8-4099-BCEB-FDADA38D8DF3}"/>
               </a:ext>
             </a:extLst>
           </p:cNvPr>
@@ -4910,7 +4910,7 @@
           <p:cNvPr id="6" name="">
             <a:extLst xmlns:a="http://schemas.openxmlformats.org/drawingml/2006/main">
               <a:ext uri="{FF2B5EF4-FFF2-40B4-BE49-F238E27FC236}">
-                <a16:creationId xmlns:a16="http://schemas.microsoft.com/office/drawing/2014/main" id="{5089FE0B-1070-4FC4-B31A-7F7341CC0BDA}"/>
+                <a16:creationId xmlns:a16="http://schemas.microsoft.com/office/drawing/2014/main" id="{1D8D54DB-AE53-495D-BE45-91DDB7F1C62A}"/>
               </a:ext>
             </a:extLst>
           </p:cNvPr>
@@ -4941,7 +4941,7 @@
           <p:cNvPr id="7" name="">
             <a:extLst xmlns:a="http://schemas.openxmlformats.org/drawingml/2006/main">
               <a:ext uri="{FF2B5EF4-FFF2-40B4-BE49-F238E27FC236}">
-                <a16:creationId xmlns:a16="http://schemas.microsoft.com/office/drawing/2014/main" id="{157B428B-132B-43E0-95EB-A7D3C886750E}"/>
+                <a16:creationId xmlns:a16="http://schemas.microsoft.com/office/drawing/2014/main" id="{0E0D8364-D03F-4634-917D-0E9FD060A08E}"/>
               </a:ext>
             </a:extLst>
           </p:cNvPr>
@@ -5002,7 +5002,7 @@
           <p:cNvPr id="8" name="">
             <a:extLst xmlns:a="http://schemas.openxmlformats.org/drawingml/2006/main">
               <a:ext uri="{FF2B5EF4-FFF2-40B4-BE49-F238E27FC236}">
-                <a16:creationId xmlns:a16="http://schemas.microsoft.com/office/drawing/2014/main" id="{834207DD-5761-47F5-9955-F395748CFF7F}"/>
+                <a16:creationId xmlns:a16="http://schemas.microsoft.com/office/drawing/2014/main" id="{A92FC325-A727-44B9-B846-2581FD948F7D}"/>
               </a:ext>
             </a:extLst>
           </p:cNvPr>
@@ -5033,7 +5033,7 @@
           <p:cNvPr id="9" name="">
             <a:extLst xmlns:a="http://schemas.openxmlformats.org/drawingml/2006/main">
               <a:ext uri="{FF2B5EF4-FFF2-40B4-BE49-F238E27FC236}">
-                <a16:creationId xmlns:a16="http://schemas.microsoft.com/office/drawing/2014/main" id="{5137A72A-4B3D-4629-8F8F-D8F78E40320A}"/>
+                <a16:creationId xmlns:a16="http://schemas.microsoft.com/office/drawing/2014/main" id="{7EB73320-A9A0-4341-BF12-44DC8419426C}"/>
               </a:ext>
             </a:extLst>
           </p:cNvPr>
@@ -5064,7 +5064,7 @@
           <p:cNvPr id="10" name="">
             <a:extLst xmlns:a="http://schemas.openxmlformats.org/drawingml/2006/main">
               <a:ext uri="{FF2B5EF4-FFF2-40B4-BE49-F238E27FC236}">
-                <a16:creationId xmlns:a16="http://schemas.microsoft.com/office/drawing/2014/main" id="{475A7DE2-6DBB-412F-BE73-1639339CE1BC}"/>
+                <a16:creationId xmlns:a16="http://schemas.microsoft.com/office/drawing/2014/main" id="{431542F5-FBF2-4D21-A322-95DDD55EECD8}"/>
               </a:ext>
             </a:extLst>
           </p:cNvPr>
@@ -5125,7 +5125,7 @@
           <p:cNvPr id="11" name="">
             <a:extLst xmlns:a="http://schemas.openxmlformats.org/drawingml/2006/main">
               <a:ext uri="{FF2B5EF4-FFF2-40B4-BE49-F238E27FC236}">
-                <a16:creationId xmlns:a16="http://schemas.microsoft.com/office/drawing/2014/main" id="{C2F03B69-EC27-44BD-8C22-33D49D157BE9}"/>
+                <a16:creationId xmlns:a16="http://schemas.microsoft.com/office/drawing/2014/main" id="{C9F449A7-0BE2-4BD7-B96D-8F5B3B42EF3D}"/>
               </a:ext>
             </a:extLst>
           </p:cNvPr>
@@ -5158,7 +5158,7 @@
           <p:cNvPr id="12" name="">
             <a:extLst xmlns:a="http://schemas.openxmlformats.org/drawingml/2006/main">
               <a:ext uri="{FF2B5EF4-FFF2-40B4-BE49-F238E27FC236}">
-                <a16:creationId xmlns:a16="http://schemas.microsoft.com/office/drawing/2014/main" id="{CEF4F09D-7D16-4C02-A260-A77DEDCAC8A2}"/>
+                <a16:creationId xmlns:a16="http://schemas.microsoft.com/office/drawing/2014/main" id="{60807C9F-DB7A-4F32-BB79-0699EE8D4104}"/>
               </a:ext>
             </a:extLst>
           </p:cNvPr>
@@ -5219,7 +5219,7 @@
           <p:cNvPr id="13" name="">
             <a:extLst xmlns:a="http://schemas.openxmlformats.org/drawingml/2006/main">
               <a:ext uri="{FF2B5EF4-FFF2-40B4-BE49-F238E27FC236}">
-                <a16:creationId xmlns:a16="http://schemas.microsoft.com/office/drawing/2014/main" id="{0494D271-4820-4906-950C-441AAA2DA64E}"/>
+                <a16:creationId xmlns:a16="http://schemas.microsoft.com/office/drawing/2014/main" id="{82DBEE2E-B345-4DC2-9A82-B80C4EB1CC4E}"/>
               </a:ext>
             </a:extLst>
           </p:cNvPr>
@@ -5280,7 +5280,7 @@
           <p:cNvPr id="14" name="">
             <a:extLst xmlns:a="http://schemas.openxmlformats.org/drawingml/2006/main">
               <a:ext uri="{FF2B5EF4-FFF2-40B4-BE49-F238E27FC236}">
-                <a16:creationId xmlns:a16="http://schemas.microsoft.com/office/drawing/2014/main" id="{CF26D163-AB05-4611-8591-84C36ED046A7}"/>
+                <a16:creationId xmlns:a16="http://schemas.microsoft.com/office/drawing/2014/main" id="{62BE1403-4709-45C0-BBB3-E70BD3302BB8}"/>
               </a:ext>
             </a:extLst>
           </p:cNvPr>
@@ -5313,7 +5313,7 @@
           <p:cNvPr id="15" name="">
             <a:extLst xmlns:a="http://schemas.openxmlformats.org/drawingml/2006/main">
               <a:ext uri="{FF2B5EF4-FFF2-40B4-BE49-F238E27FC236}">
-                <a16:creationId xmlns:a16="http://schemas.microsoft.com/office/drawing/2014/main" id="{B2B33C41-B4D4-40FD-95D6-683716105BC8}"/>
+                <a16:creationId xmlns:a16="http://schemas.microsoft.com/office/drawing/2014/main" id="{2360E56A-996E-4861-B65B-0B11986E83BA}"/>
               </a:ext>
             </a:extLst>
           </p:cNvPr>
@@ -5374,7 +5374,7 @@
           <p:cNvPr id="16" name="">
             <a:extLst xmlns:a="http://schemas.openxmlformats.org/drawingml/2006/main">
               <a:ext uri="{FF2B5EF4-FFF2-40B4-BE49-F238E27FC236}">
-                <a16:creationId xmlns:a16="http://schemas.microsoft.com/office/drawing/2014/main" id="{98E7ED3A-D4EB-4F79-AC02-95136325D446}"/>
+                <a16:creationId xmlns:a16="http://schemas.microsoft.com/office/drawing/2014/main" id="{CB5B2108-03D4-4C3E-A62B-803097C5CA40}"/>
               </a:ext>
             </a:extLst>
           </p:cNvPr>
@@ -5435,7 +5435,7 @@
           <p:cNvPr id="17" name="">
             <a:extLst xmlns:a="http://schemas.openxmlformats.org/drawingml/2006/main">
               <a:ext uri="{FF2B5EF4-FFF2-40B4-BE49-F238E27FC236}">
-                <a16:creationId xmlns:a16="http://schemas.microsoft.com/office/drawing/2014/main" id="{0DB3EB40-F548-4192-B9D5-7A042AE900EF}"/>
+                <a16:creationId xmlns:a16="http://schemas.microsoft.com/office/drawing/2014/main" id="{738F2C29-288F-4B27-888D-DEA78F273E82}"/>
               </a:ext>
             </a:extLst>
           </p:cNvPr>
@@ -5468,7 +5468,7 @@
           <p:cNvPr id="18" name="">
             <a:extLst xmlns:a="http://schemas.openxmlformats.org/drawingml/2006/main">
               <a:ext uri="{FF2B5EF4-FFF2-40B4-BE49-F238E27FC236}">
-                <a16:creationId xmlns:a16="http://schemas.microsoft.com/office/drawing/2014/main" id="{AC8DF998-5B29-4844-AAD6-6189EA130882}"/>
+                <a16:creationId xmlns:a16="http://schemas.microsoft.com/office/drawing/2014/main" id="{F62EFA87-1721-495C-82B1-5E282941E45F}"/>
               </a:ext>
             </a:extLst>
           </p:cNvPr>
@@ -5529,7 +5529,7 @@
           <p:cNvPr id="19" name="">
             <a:extLst xmlns:a="http://schemas.openxmlformats.org/drawingml/2006/main">
               <a:ext uri="{FF2B5EF4-FFF2-40B4-BE49-F238E27FC236}">
-                <a16:creationId xmlns:a16="http://schemas.microsoft.com/office/drawing/2014/main" id="{330C9BCF-5E79-4EF9-B6A0-702DCC316C5F}"/>
+                <a16:creationId xmlns:a16="http://schemas.microsoft.com/office/drawing/2014/main" id="{98C60C1B-7A43-4A61-AD10-069BDEE1A71C}"/>
               </a:ext>
             </a:extLst>
           </p:cNvPr>
@@ -5590,7 +5590,7 @@
           <p:cNvPr id="20" name="">
             <a:extLst xmlns:a="http://schemas.openxmlformats.org/drawingml/2006/main">
               <a:ext uri="{FF2B5EF4-FFF2-40B4-BE49-F238E27FC236}">
-                <a16:creationId xmlns:a16="http://schemas.microsoft.com/office/drawing/2014/main" id="{A400861E-FDF5-4AB9-A836-51E51059BFD9}"/>
+                <a16:creationId xmlns:a16="http://schemas.microsoft.com/office/drawing/2014/main" id="{2B5D404B-E837-4B1A-A024-FEA9819F5AF9}"/>
               </a:ext>
             </a:extLst>
           </p:cNvPr>
@@ -5623,7 +5623,7 @@
           <p:cNvPr id="21" name="">
             <a:extLst xmlns:a="http://schemas.openxmlformats.org/drawingml/2006/main">
               <a:ext uri="{FF2B5EF4-FFF2-40B4-BE49-F238E27FC236}">
-                <a16:creationId xmlns:a16="http://schemas.microsoft.com/office/drawing/2014/main" id="{D9843D57-24CC-403C-B524-1AC35460E81D}"/>
+                <a16:creationId xmlns:a16="http://schemas.microsoft.com/office/drawing/2014/main" id="{440E9091-F36E-449F-A066-473CE42B292D}"/>
               </a:ext>
             </a:extLst>
           </p:cNvPr>
@@ -5684,7 +5684,7 @@
           <p:cNvPr id="22" name="">
             <a:extLst xmlns:a="http://schemas.openxmlformats.org/drawingml/2006/main">
               <a:ext uri="{FF2B5EF4-FFF2-40B4-BE49-F238E27FC236}">
-                <a16:creationId xmlns:a16="http://schemas.microsoft.com/office/drawing/2014/main" id="{25C809A2-F244-421C-A6A8-098CFA1BDBE2}"/>
+                <a16:creationId xmlns:a16="http://schemas.microsoft.com/office/drawing/2014/main" id="{342E4C87-3994-4504-B2EB-AB8789F598AB}"/>
               </a:ext>
             </a:extLst>
           </p:cNvPr>
@@ -5745,7 +5745,7 @@
           <p:cNvPr id="23" name="">
             <a:extLst xmlns:a="http://schemas.openxmlformats.org/drawingml/2006/main">
               <a:ext uri="{FF2B5EF4-FFF2-40B4-BE49-F238E27FC236}">
-                <a16:creationId xmlns:a16="http://schemas.microsoft.com/office/drawing/2014/main" id="{F9C67023-1D47-4AFF-8AFD-0C680912C50C}"/>
+                <a16:creationId xmlns:a16="http://schemas.microsoft.com/office/drawing/2014/main" id="{24979EC6-3652-477D-B43D-475C17519262}"/>
               </a:ext>
             </a:extLst>
           </p:cNvPr>
@@ -5778,7 +5778,7 @@
           <p:cNvPr id="24" name="">
             <a:extLst xmlns:a="http://schemas.openxmlformats.org/drawingml/2006/main">
               <a:ext uri="{FF2B5EF4-FFF2-40B4-BE49-F238E27FC236}">
-                <a16:creationId xmlns:a16="http://schemas.microsoft.com/office/drawing/2014/main" id="{B042B9B0-DB18-4CEF-AB34-51FB9BF66E99}"/>
+                <a16:creationId xmlns:a16="http://schemas.microsoft.com/office/drawing/2014/main" id="{7DD418EE-2B8F-4C6E-9196-A4AAFA5FA57C}"/>
               </a:ext>
             </a:extLst>
           </p:cNvPr>
@@ -5839,7 +5839,7 @@
           <p:cNvPr id="25" name="">
             <a:extLst xmlns:a="http://schemas.openxmlformats.org/drawingml/2006/main">
               <a:ext uri="{FF2B5EF4-FFF2-40B4-BE49-F238E27FC236}">
-                <a16:creationId xmlns:a16="http://schemas.microsoft.com/office/drawing/2014/main" id="{5B36D55C-1662-451D-94F1-64AA8C48B051}"/>
+                <a16:creationId xmlns:a16="http://schemas.microsoft.com/office/drawing/2014/main" id="{CA6FD4D4-1AD5-4E6A-A41F-7320B1171EB4}"/>
               </a:ext>
             </a:extLst>
           </p:cNvPr>
@@ -5870,7 +5870,7 @@
           <p:cNvPr id="26" name="">
             <a:extLst xmlns:a="http://schemas.openxmlformats.org/drawingml/2006/main">
               <a:ext uri="{FF2B5EF4-FFF2-40B4-BE49-F238E27FC236}">
-                <a16:creationId xmlns:a16="http://schemas.microsoft.com/office/drawing/2014/main" id="{893D33DD-F7BD-44C8-9ED2-E2BB0A890320}"/>
+                <a16:creationId xmlns:a16="http://schemas.microsoft.com/office/drawing/2014/main" id="{8FE30956-287D-4473-9467-F58CD486F3DB}"/>
               </a:ext>
             </a:extLst>
           </p:cNvPr>
@@ -5903,7 +5903,7 @@
           <p:cNvPr id="27" name="">
             <a:extLst xmlns:a="http://schemas.openxmlformats.org/drawingml/2006/main">
               <a:ext uri="{FF2B5EF4-FFF2-40B4-BE49-F238E27FC236}">
-                <a16:creationId xmlns:a16="http://schemas.microsoft.com/office/drawing/2014/main" id="{1C0FE9A3-1266-41D2-9277-5B8CCC24F943}"/>
+                <a16:creationId xmlns:a16="http://schemas.microsoft.com/office/drawing/2014/main" id="{E96EA64F-ACFA-4453-9F48-6A2B21090821}"/>
               </a:ext>
             </a:extLst>
           </p:cNvPr>
@@ -5964,7 +5964,7 @@
           <p:cNvPr id="28" name="">
             <a:extLst xmlns:a="http://schemas.openxmlformats.org/drawingml/2006/main">
               <a:ext uri="{FF2B5EF4-FFF2-40B4-BE49-F238E27FC236}">
-                <a16:creationId xmlns:a16="http://schemas.microsoft.com/office/drawing/2014/main" id="{C0EFF34C-1A99-4BC1-B08E-74BB63C63D99}"/>
+                <a16:creationId xmlns:a16="http://schemas.microsoft.com/office/drawing/2014/main" id="{471710A1-64E1-4329-94C3-D79B370BAD18}"/>
               </a:ext>
             </a:extLst>
           </p:cNvPr>
@@ -6025,7 +6025,7 @@
           <p:cNvPr id="29" name="">
             <a:extLst xmlns:a="http://schemas.openxmlformats.org/drawingml/2006/main">
               <a:ext uri="{FF2B5EF4-FFF2-40B4-BE49-F238E27FC236}">
-                <a16:creationId xmlns:a16="http://schemas.microsoft.com/office/drawing/2014/main" id="{C841560A-8868-459B-ABD3-E6104DD29CA7}"/>
+                <a16:creationId xmlns:a16="http://schemas.microsoft.com/office/drawing/2014/main" id="{FEC30898-6455-4F51-9BF6-E7AB2967EAE9}"/>
               </a:ext>
             </a:extLst>
           </p:cNvPr>
@@ -6086,7 +6086,7 @@
           <p:cNvPr id="30" name="">
             <a:extLst xmlns:a="http://schemas.openxmlformats.org/drawingml/2006/main">
               <a:ext uri="{FF2B5EF4-FFF2-40B4-BE49-F238E27FC236}">
-                <a16:creationId xmlns:a16="http://schemas.microsoft.com/office/drawing/2014/main" id="{B1D7E23B-6FCE-43FC-A728-A3E176CAF277}"/>
+                <a16:creationId xmlns:a16="http://schemas.microsoft.com/office/drawing/2014/main" id="{D8000DAC-8238-41A5-89D7-0ACA145C9FDE}"/>
               </a:ext>
             </a:extLst>
           </p:cNvPr>
@@ -6117,7 +6117,7 @@
           <p:cNvPr id="31" name="">
             <a:extLst xmlns:a="http://schemas.openxmlformats.org/drawingml/2006/main">
               <a:ext uri="{FF2B5EF4-FFF2-40B4-BE49-F238E27FC236}">
-                <a16:creationId xmlns:a16="http://schemas.microsoft.com/office/drawing/2014/main" id="{7EA8299D-6CB8-45FA-9143-0702BA5C978C}"/>
+                <a16:creationId xmlns:a16="http://schemas.microsoft.com/office/drawing/2014/main" id="{E15137CD-98CE-4DAF-A75A-823150C8305E}"/>
               </a:ext>
             </a:extLst>
           </p:cNvPr>
@@ -6178,7 +6178,7 @@
           <p:cNvPr id="32" name="">
             <a:extLst xmlns:a="http://schemas.openxmlformats.org/drawingml/2006/main">
               <a:ext uri="{FF2B5EF4-FFF2-40B4-BE49-F238E27FC236}">
-                <a16:creationId xmlns:a16="http://schemas.microsoft.com/office/drawing/2014/main" id="{F12C4494-9CB7-4BB6-9A05-45D645CE9FD6}"/>
+                <a16:creationId xmlns:a16="http://schemas.microsoft.com/office/drawing/2014/main" id="{5CB4AE01-085C-4F8B-A2E2-9759048B593D}"/>
               </a:ext>
             </a:extLst>
           </p:cNvPr>
@@ -6239,7 +6239,7 @@
           <p:cNvPr id="33" name="">
             <a:extLst xmlns:a="http://schemas.openxmlformats.org/drawingml/2006/main">
               <a:ext uri="{FF2B5EF4-FFF2-40B4-BE49-F238E27FC236}">
-                <a16:creationId xmlns:a16="http://schemas.microsoft.com/office/drawing/2014/main" id="{8F157332-1AE6-4848-B4E2-8B6F641069AD}"/>
+                <a16:creationId xmlns:a16="http://schemas.microsoft.com/office/drawing/2014/main" id="{09D68673-C09D-4380-BE4F-9A8DEFE4FE21}"/>
               </a:ext>
             </a:extLst>
           </p:cNvPr>
@@ -6300,7 +6300,7 @@
           <p:cNvPr id="34" name="">
             <a:extLst xmlns:a="http://schemas.openxmlformats.org/drawingml/2006/main">
               <a:ext uri="{FF2B5EF4-FFF2-40B4-BE49-F238E27FC236}">
-                <a16:creationId xmlns:a16="http://schemas.microsoft.com/office/drawing/2014/main" id="{EAAD0B02-DDD7-4C6E-8A97-CEBB9187A440}"/>
+                <a16:creationId xmlns:a16="http://schemas.microsoft.com/office/drawing/2014/main" id="{230A22F0-38B9-4F81-AED1-7705B0F5BC8D}"/>
               </a:ext>
             </a:extLst>
           </p:cNvPr>
@@ -6361,7 +6361,7 @@
           <p:cNvPr id="35" name="">
             <a:extLst xmlns:a="http://schemas.openxmlformats.org/drawingml/2006/main">
               <a:ext uri="{FF2B5EF4-FFF2-40B4-BE49-F238E27FC236}">
-                <a16:creationId xmlns:a16="http://schemas.microsoft.com/office/drawing/2014/main" id="{FC60ED5D-7A3C-42BC-ABB2-C4D398F72D2A}"/>
+                <a16:creationId xmlns:a16="http://schemas.microsoft.com/office/drawing/2014/main" id="{595D6B36-7EBC-4BAD-AF76-944C04B65F39}"/>
               </a:ext>
             </a:extLst>
           </p:cNvPr>
@@ -6392,7 +6392,7 @@
           <p:cNvPr id="36" name="">
             <a:extLst xmlns:a="http://schemas.openxmlformats.org/drawingml/2006/main">
               <a:ext uri="{FF2B5EF4-FFF2-40B4-BE49-F238E27FC236}">
-                <a16:creationId xmlns:a16="http://schemas.microsoft.com/office/drawing/2014/main" id="{EF8903BD-6FB9-4085-86A1-22CEE37B452E}"/>
+                <a16:creationId xmlns:a16="http://schemas.microsoft.com/office/drawing/2014/main" id="{E48237D5-F413-48BC-AEED-ACC7CD9045BB}"/>
               </a:ext>
             </a:extLst>
           </p:cNvPr>
@@ -6443,7 +6443,7 @@
                 <a:ea typeface="Arial"/>
                 <a:cs typeface="Arial"/>
               </a:rPr>
-              <a:t>FORMULABENCH  ·  RESEARCH / TRACK 2</a:t>
+              <a:t>FORMULABENCH  ·  RESEARCH: EXCEL FORMULA GENERATION</a:t>
             </a:r>
           </a:p>
         </p:txBody>
@@ -6453,7 +6453,7 @@
           <p:cNvPr id="37" name="">
             <a:extLst xmlns:a="http://schemas.openxmlformats.org/drawingml/2006/main">
               <a:ext uri="{FF2B5EF4-FFF2-40B4-BE49-F238E27FC236}">
-                <a16:creationId xmlns:a16="http://schemas.microsoft.com/office/drawing/2014/main" id="{39664913-30EA-4553-9654-0230C96612B4}"/>
+                <a16:creationId xmlns:a16="http://schemas.microsoft.com/office/drawing/2014/main" id="{1DD9EAAC-0ACA-495E-816A-93EC45B5E67C}"/>
               </a:ext>
             </a:extLst>
           </p:cNvPr>
@@ -6512,7 +6512,7 @@
     </p:spTree>
     <p:extLst>
       <p:ext uri="{BB962C8B-B14F-4D97-AF65-F5344CB8AC3E}">
-        <p14:creationId xmlns:p14="http://schemas.microsoft.com/office/powerpoint/2010/main" val="1362314503"/>
+        <p14:creationId xmlns:p14="http://schemas.microsoft.com/office/powerpoint/2010/main" val="1399336237"/>
       </p:ext>
     </p:extLst>
   </p:cSld>
@@ -6543,7 +6543,7 @@
           <p:cNvPr id="8" name="slide-title">
             <a:extLst xmlns:a="http://schemas.openxmlformats.org/drawingml/2006/main">
               <a:ext uri="{FF2B5EF4-FFF2-40B4-BE49-F238E27FC236}">
-                <a16:creationId xmlns:a16="http://schemas.microsoft.com/office/drawing/2014/main" id="{05EACF2E-8CE8-4C61-8401-85A32F2174DC}"/>
+                <a16:creationId xmlns:a16="http://schemas.microsoft.com/office/drawing/2014/main" id="{934DEE5C-EA7B-49BD-BA8B-FB886F715CC1}"/>
               </a:ext>
             </a:extLst>
           </p:cNvPr>
@@ -6604,7 +6604,7 @@
           <p:cNvPr id="2" name="">
             <a:extLst xmlns:a="http://schemas.openxmlformats.org/drawingml/2006/main">
               <a:ext uri="{FF2B5EF4-FFF2-40B4-BE49-F238E27FC236}">
-                <a16:creationId xmlns:a16="http://schemas.microsoft.com/office/drawing/2014/main" id="{7CE5D7BA-080F-4EA9-B3E3-01C0BAE89666}"/>
+                <a16:creationId xmlns:a16="http://schemas.microsoft.com/office/drawing/2014/main" id="{1BA648A0-2155-4DAB-BC20-4E95F6A573B5}"/>
               </a:ext>
             </a:extLst>
           </p:cNvPr>
@@ -7118,7 +7118,7 @@
           <p:cNvPr id="4" name="">
             <a:extLst xmlns:a="http://schemas.openxmlformats.org/drawingml/2006/main">
               <a:ext uri="{FF2B5EF4-FFF2-40B4-BE49-F238E27FC236}">
-                <a16:creationId xmlns:a16="http://schemas.microsoft.com/office/drawing/2014/main" id="{9DF36416-CAE1-4B08-AD69-8DED034D2240}"/>
+                <a16:creationId xmlns:a16="http://schemas.microsoft.com/office/drawing/2014/main" id="{2B0003E5-CE5C-49BB-87D2-E502D8D40A39}"/>
               </a:ext>
             </a:extLst>
           </p:cNvPr>
@@ -7179,7 +7179,7 @@
           <p:cNvPr id="5" name="">
             <a:extLst xmlns:a="http://schemas.openxmlformats.org/drawingml/2006/main">
               <a:ext uri="{FF2B5EF4-FFF2-40B4-BE49-F238E27FC236}">
-                <a16:creationId xmlns:a16="http://schemas.microsoft.com/office/drawing/2014/main" id="{084CF18C-0618-4405-A1BD-5C49D9C318FB}"/>
+                <a16:creationId xmlns:a16="http://schemas.microsoft.com/office/drawing/2014/main" id="{DE1B28C0-A66D-426D-A731-C468B74DE1A9}"/>
               </a:ext>
             </a:extLst>
           </p:cNvPr>
@@ -7210,7 +7210,7 @@
           <p:cNvPr id="6" name="">
             <a:extLst xmlns:a="http://schemas.openxmlformats.org/drawingml/2006/main">
               <a:ext uri="{FF2B5EF4-FFF2-40B4-BE49-F238E27FC236}">
-                <a16:creationId xmlns:a16="http://schemas.microsoft.com/office/drawing/2014/main" id="{91B9C88E-8783-4EF5-8491-E504FFFB65B0}"/>
+                <a16:creationId xmlns:a16="http://schemas.microsoft.com/office/drawing/2014/main" id="{E9B17D3F-8DD2-4C95-BFD0-A507996C769A}"/>
               </a:ext>
             </a:extLst>
           </p:cNvPr>
@@ -7261,7 +7261,7 @@
                 <a:ea typeface="Arial"/>
                 <a:cs typeface="Arial"/>
               </a:rPr>
-              <a:t>FORMULABENCH  ·  RESEARCH / TRACK 2</a:t>
+              <a:t>FORMULABENCH  ·  RESEARCH: EXCEL FORMULA GENERATION</a:t>
             </a:r>
           </a:p>
         </p:txBody>
@@ -7271,7 +7271,7 @@
           <p:cNvPr id="7" name="">
             <a:extLst xmlns:a="http://schemas.openxmlformats.org/drawingml/2006/main">
               <a:ext uri="{FF2B5EF4-FFF2-40B4-BE49-F238E27FC236}">
-                <a16:creationId xmlns:a16="http://schemas.microsoft.com/office/drawing/2014/main" id="{29093E58-55D0-4F69-ACFF-3BBD3B158314}"/>
+                <a16:creationId xmlns:a16="http://schemas.microsoft.com/office/drawing/2014/main" id="{C60F3EA8-AC59-4676-B447-9D67BEB2E05E}"/>
               </a:ext>
             </a:extLst>
           </p:cNvPr>
@@ -7330,7 +7330,7 @@
     </p:spTree>
     <p:extLst>
       <p:ext uri="{BB962C8B-B14F-4D97-AF65-F5344CB8AC3E}">
-        <p14:creationId xmlns:p14="http://schemas.microsoft.com/office/powerpoint/2010/main" val="1200794271"/>
+        <p14:creationId xmlns:p14="http://schemas.microsoft.com/office/powerpoint/2010/main" val="1619384628"/>
       </p:ext>
     </p:extLst>
   </p:cSld>
@@ -7361,7 +7361,7 @@
           <p:cNvPr id="14" name="slide-title">
             <a:extLst xmlns:a="http://schemas.openxmlformats.org/drawingml/2006/main">
               <a:ext uri="{FF2B5EF4-FFF2-40B4-BE49-F238E27FC236}">
-                <a16:creationId xmlns:a16="http://schemas.microsoft.com/office/drawing/2014/main" id="{689BA516-2213-496F-9363-6208C6577F87}"/>
+                <a16:creationId xmlns:a16="http://schemas.microsoft.com/office/drawing/2014/main" id="{DC6E3B83-E3DB-4FAA-806F-0E6AA7EEF1A7}"/>
               </a:ext>
             </a:extLst>
           </p:cNvPr>
@@ -7422,7 +7422,7 @@
           <p:cNvPr id="2" name="">
             <a:extLst xmlns:a="http://schemas.openxmlformats.org/drawingml/2006/main">
               <a:ext uri="{FF2B5EF4-FFF2-40B4-BE49-F238E27FC236}">
-                <a16:creationId xmlns:a16="http://schemas.microsoft.com/office/drawing/2014/main" id="{5FEECD80-0C79-4710-A7B5-811F4E849C0B}"/>
+                <a16:creationId xmlns:a16="http://schemas.microsoft.com/office/drawing/2014/main" id="{1C7E72CD-5C12-4A6B-BCA2-27972ED9FB81}"/>
               </a:ext>
             </a:extLst>
           </p:cNvPr>
@@ -7490,7 +7490,7 @@
         </p:xfrm>
         <a:graphic xmlns:a="http://schemas.openxmlformats.org/drawingml/2006/main">
           <a:graphicData uri="http://schemas.openxmlformats.org/drawingml/2006/chart">
-            <c:chart xmlns:r="http://schemas.openxmlformats.org/officeDocument/2006/relationships" xmlns:c="http://schemas.openxmlformats.org/drawingml/2006/chart" r:id="Ra6cd158e5f2c4ee8"/>
+            <c:chart xmlns:r="http://schemas.openxmlformats.org/officeDocument/2006/relationships" xmlns:c="http://schemas.openxmlformats.org/drawingml/2006/chart" r:id="R2b47a07c53524778"/>
           </a:graphicData>
         </a:graphic>
       </p:graphicFrame>
@@ -7499,7 +7499,7 @@
           <p:cNvPr id="4" name="">
             <a:extLst xmlns:a="http://schemas.openxmlformats.org/drawingml/2006/main">
               <a:ext uri="{FF2B5EF4-FFF2-40B4-BE49-F238E27FC236}">
-                <a16:creationId xmlns:a16="http://schemas.microsoft.com/office/drawing/2014/main" id="{209E82BD-043A-401B-B844-3F3965E39D1C}"/>
+                <a16:creationId xmlns:a16="http://schemas.microsoft.com/office/drawing/2014/main" id="{A3372F17-8199-49AA-8B13-B91399BB793A}"/>
               </a:ext>
             </a:extLst>
           </p:cNvPr>
@@ -7560,7 +7560,7 @@
           <p:cNvPr id="5" name="">
             <a:extLst xmlns:a="http://schemas.openxmlformats.org/drawingml/2006/main">
               <a:ext uri="{FF2B5EF4-FFF2-40B4-BE49-F238E27FC236}">
-                <a16:creationId xmlns:a16="http://schemas.microsoft.com/office/drawing/2014/main" id="{79E3E75A-695E-4952-83E2-8213916499E9}"/>
+                <a16:creationId xmlns:a16="http://schemas.microsoft.com/office/drawing/2014/main" id="{D421D889-C2DB-4D44-ABDC-FBACC738B478}"/>
               </a:ext>
             </a:extLst>
           </p:cNvPr>
@@ -7621,7 +7621,7 @@
           <p:cNvPr id="6" name="">
             <a:extLst xmlns:a="http://schemas.openxmlformats.org/drawingml/2006/main">
               <a:ext uri="{FF2B5EF4-FFF2-40B4-BE49-F238E27FC236}">
-                <a16:creationId xmlns:a16="http://schemas.microsoft.com/office/drawing/2014/main" id="{8CC4E20E-CCB4-4B7A-9B3E-0CE4FE59CC3E}"/>
+                <a16:creationId xmlns:a16="http://schemas.microsoft.com/office/drawing/2014/main" id="{57315F70-C7F7-4BAA-B1DC-FADDF3F484C9}"/>
               </a:ext>
             </a:extLst>
           </p:cNvPr>
@@ -7652,7 +7652,7 @@
           <p:cNvPr id="7" name="">
             <a:extLst xmlns:a="http://schemas.openxmlformats.org/drawingml/2006/main">
               <a:ext uri="{FF2B5EF4-FFF2-40B4-BE49-F238E27FC236}">
-                <a16:creationId xmlns:a16="http://schemas.microsoft.com/office/drawing/2014/main" id="{C5E53A0A-98C9-476B-B61A-54A9161B6503}"/>
+                <a16:creationId xmlns:a16="http://schemas.microsoft.com/office/drawing/2014/main" id="{A4E65CEF-485B-42AF-9C4C-0D79EF3A0EA8}"/>
               </a:ext>
             </a:extLst>
           </p:cNvPr>
@@ -7713,7 +7713,7 @@
           <p:cNvPr id="8" name="">
             <a:extLst xmlns:a="http://schemas.openxmlformats.org/drawingml/2006/main">
               <a:ext uri="{FF2B5EF4-FFF2-40B4-BE49-F238E27FC236}">
-                <a16:creationId xmlns:a16="http://schemas.microsoft.com/office/drawing/2014/main" id="{336E72AD-7301-400F-B909-8F1E7119B12C}"/>
+                <a16:creationId xmlns:a16="http://schemas.microsoft.com/office/drawing/2014/main" id="{F80BD622-B39D-4D66-8464-CF2AA968D01E}"/>
               </a:ext>
             </a:extLst>
           </p:cNvPr>
@@ -7774,7 +7774,7 @@
           <p:cNvPr id="9" name="">
             <a:extLst xmlns:a="http://schemas.openxmlformats.org/drawingml/2006/main">
               <a:ext uri="{FF2B5EF4-FFF2-40B4-BE49-F238E27FC236}">
-                <a16:creationId xmlns:a16="http://schemas.microsoft.com/office/drawing/2014/main" id="{353405E8-1A0A-4D34-9682-3E07720C9A13}"/>
+                <a16:creationId xmlns:a16="http://schemas.microsoft.com/office/drawing/2014/main" id="{D20203A2-725B-43BF-A61E-F6374AA3AE5E}"/>
               </a:ext>
             </a:extLst>
           </p:cNvPr>
@@ -7862,7 +7862,7 @@
           <p:cNvPr id="10" name="">
             <a:extLst xmlns:a="http://schemas.openxmlformats.org/drawingml/2006/main">
               <a:ext uri="{FF2B5EF4-FFF2-40B4-BE49-F238E27FC236}">
-                <a16:creationId xmlns:a16="http://schemas.microsoft.com/office/drawing/2014/main" id="{41C2428C-7ECF-4E59-B891-DE23AFE30AE2}"/>
+                <a16:creationId xmlns:a16="http://schemas.microsoft.com/office/drawing/2014/main" id="{EA9FEF13-27A2-4740-8025-D7245E4701C4}"/>
               </a:ext>
             </a:extLst>
           </p:cNvPr>
@@ -7923,7 +7923,7 @@
           <p:cNvPr id="11" name="">
             <a:extLst xmlns:a="http://schemas.openxmlformats.org/drawingml/2006/main">
               <a:ext uri="{FF2B5EF4-FFF2-40B4-BE49-F238E27FC236}">
-                <a16:creationId xmlns:a16="http://schemas.microsoft.com/office/drawing/2014/main" id="{29DE7052-49E5-4F2D-B3DE-25645D08F636}"/>
+                <a16:creationId xmlns:a16="http://schemas.microsoft.com/office/drawing/2014/main" id="{B1EFD6A5-ADE2-4E35-9C07-39007C5C7E25}"/>
               </a:ext>
             </a:extLst>
           </p:cNvPr>
@@ -7954,7 +7954,7 @@
           <p:cNvPr id="12" name="">
             <a:extLst xmlns:a="http://schemas.openxmlformats.org/drawingml/2006/main">
               <a:ext uri="{FF2B5EF4-FFF2-40B4-BE49-F238E27FC236}">
-                <a16:creationId xmlns:a16="http://schemas.microsoft.com/office/drawing/2014/main" id="{73E31585-B7D1-481E-909C-B11A7142489A}"/>
+                <a16:creationId xmlns:a16="http://schemas.microsoft.com/office/drawing/2014/main" id="{1E288709-6F7B-44B1-AE89-70DC61AB0F6B}"/>
               </a:ext>
             </a:extLst>
           </p:cNvPr>
@@ -8005,7 +8005,7 @@
                 <a:ea typeface="Arial"/>
                 <a:cs typeface="Arial"/>
               </a:rPr>
-              <a:t>FORMULABENCH  ·  RESEARCH / TRACK 2</a:t>
+              <a:t>FORMULABENCH  ·  RESEARCH: EXCEL FORMULA GENERATION</a:t>
             </a:r>
           </a:p>
         </p:txBody>
@@ -8015,7 +8015,7 @@
           <p:cNvPr id="13" name="">
             <a:extLst xmlns:a="http://schemas.openxmlformats.org/drawingml/2006/main">
               <a:ext uri="{FF2B5EF4-FFF2-40B4-BE49-F238E27FC236}">
-                <a16:creationId xmlns:a16="http://schemas.microsoft.com/office/drawing/2014/main" id="{18DD0D77-DA2C-4FA4-890E-37A12C0A99A2}"/>
+                <a16:creationId xmlns:a16="http://schemas.microsoft.com/office/drawing/2014/main" id="{73057E85-8DA4-471C-9F41-899173D0E632}"/>
               </a:ext>
             </a:extLst>
           </p:cNvPr>
@@ -8074,7 +8074,7 @@
     </p:spTree>
     <p:extLst>
       <p:ext uri="{BB962C8B-B14F-4D97-AF65-F5344CB8AC3E}">
-        <p14:creationId xmlns:p14="http://schemas.microsoft.com/office/powerpoint/2010/main" val="955302236"/>
+        <p14:creationId xmlns:p14="http://schemas.microsoft.com/office/powerpoint/2010/main" val="1249322482"/>
       </p:ext>
     </p:extLst>
   </p:cSld>
@@ -8105,7 +8105,7 @@
           <p:cNvPr id="12" name="slide-title">
             <a:extLst xmlns:a="http://schemas.openxmlformats.org/drawingml/2006/main">
               <a:ext uri="{FF2B5EF4-FFF2-40B4-BE49-F238E27FC236}">
-                <a16:creationId xmlns:a16="http://schemas.microsoft.com/office/drawing/2014/main" id="{597500CD-8E6F-4A7F-B92F-05E0B1D919B9}"/>
+                <a16:creationId xmlns:a16="http://schemas.microsoft.com/office/drawing/2014/main" id="{DFE1E83B-8D21-4930-A3D0-6EEF84CD8C42}"/>
               </a:ext>
             </a:extLst>
           </p:cNvPr>
@@ -8166,7 +8166,7 @@
           <p:cNvPr id="2" name="">
             <a:extLst xmlns:a="http://schemas.openxmlformats.org/drawingml/2006/main">
               <a:ext uri="{FF2B5EF4-FFF2-40B4-BE49-F238E27FC236}">
-                <a16:creationId xmlns:a16="http://schemas.microsoft.com/office/drawing/2014/main" id="{E6F37C66-CB06-42D3-8EB0-C7A3A20567F3}"/>
+                <a16:creationId xmlns:a16="http://schemas.microsoft.com/office/drawing/2014/main" id="{B322269D-9905-40E3-A2B1-74F1F7A18347}"/>
               </a:ext>
             </a:extLst>
           </p:cNvPr>
@@ -8227,7 +8227,7 @@
           <p:cNvPr id="3" name="">
             <a:extLst xmlns:a="http://schemas.openxmlformats.org/drawingml/2006/main">
               <a:ext uri="{FF2B5EF4-FFF2-40B4-BE49-F238E27FC236}">
-                <a16:creationId xmlns:a16="http://schemas.microsoft.com/office/drawing/2014/main" id="{3B1420E9-843E-4DC4-9DAA-D64AA2BC0EAC}"/>
+                <a16:creationId xmlns:a16="http://schemas.microsoft.com/office/drawing/2014/main" id="{89C9DDF3-D769-437C-8367-306F4C7BD2EB}"/>
               </a:ext>
             </a:extLst>
           </p:cNvPr>
@@ -8288,7 +8288,7 @@
           <p:cNvPr id="4" name="">
             <a:extLst xmlns:a="http://schemas.openxmlformats.org/drawingml/2006/main">
               <a:ext uri="{FF2B5EF4-FFF2-40B4-BE49-F238E27FC236}">
-                <a16:creationId xmlns:a16="http://schemas.microsoft.com/office/drawing/2014/main" id="{FE3CA152-2CC8-4FAB-B233-25748452E51D}"/>
+                <a16:creationId xmlns:a16="http://schemas.microsoft.com/office/drawing/2014/main" id="{AE0AB10A-5FA5-4032-81ED-0A5E6626C16C}"/>
               </a:ext>
             </a:extLst>
           </p:cNvPr>
@@ -8349,7 +8349,7 @@
           <p:cNvPr id="5" name="">
             <a:extLst xmlns:a="http://schemas.openxmlformats.org/drawingml/2006/main">
               <a:ext uri="{FF2B5EF4-FFF2-40B4-BE49-F238E27FC236}">
-                <a16:creationId xmlns:a16="http://schemas.microsoft.com/office/drawing/2014/main" id="{E3464BBE-47B7-44EA-988C-4CC771B51850}"/>
+                <a16:creationId xmlns:a16="http://schemas.microsoft.com/office/drawing/2014/main" id="{03EA3DA6-0217-4F2E-BA23-E82E4BEA3500}"/>
               </a:ext>
             </a:extLst>
           </p:cNvPr>
@@ -8410,7 +8410,7 @@
           <p:cNvPr id="6" name="">
             <a:extLst xmlns:a="http://schemas.openxmlformats.org/drawingml/2006/main">
               <a:ext uri="{FF2B5EF4-FFF2-40B4-BE49-F238E27FC236}">
-                <a16:creationId xmlns:a16="http://schemas.microsoft.com/office/drawing/2014/main" id="{872538B5-C26E-464E-904E-E2FE1BD1AEDB}"/>
+                <a16:creationId xmlns:a16="http://schemas.microsoft.com/office/drawing/2014/main" id="{0CE6B10D-ED0F-48C3-A678-C6E9C614D5CB}"/>
               </a:ext>
             </a:extLst>
           </p:cNvPr>
@@ -8813,7 +8813,7 @@
           <p:cNvPr id="8" name="">
             <a:extLst xmlns:a="http://schemas.openxmlformats.org/drawingml/2006/main">
               <a:ext uri="{FF2B5EF4-FFF2-40B4-BE49-F238E27FC236}">
-                <a16:creationId xmlns:a16="http://schemas.microsoft.com/office/drawing/2014/main" id="{5BB1125E-150E-4002-B3B6-A7BD582CE0F4}"/>
+                <a16:creationId xmlns:a16="http://schemas.microsoft.com/office/drawing/2014/main" id="{018592E5-FC3F-4CD4-98ED-AFC5A9F5C172}"/>
               </a:ext>
             </a:extLst>
           </p:cNvPr>
@@ -8874,7 +8874,7 @@
           <p:cNvPr id="9" name="">
             <a:extLst xmlns:a="http://schemas.openxmlformats.org/drawingml/2006/main">
               <a:ext uri="{FF2B5EF4-FFF2-40B4-BE49-F238E27FC236}">
-                <a16:creationId xmlns:a16="http://schemas.microsoft.com/office/drawing/2014/main" id="{8BACCCC3-C59E-4036-A59C-8A16AA3D444E}"/>
+                <a16:creationId xmlns:a16="http://schemas.microsoft.com/office/drawing/2014/main" id="{706E6AC8-7968-4ACB-819A-D0F9FF0312A9}"/>
               </a:ext>
             </a:extLst>
           </p:cNvPr>
@@ -8905,7 +8905,7 @@
           <p:cNvPr id="10" name="">
             <a:extLst xmlns:a="http://schemas.openxmlformats.org/drawingml/2006/main">
               <a:ext uri="{FF2B5EF4-FFF2-40B4-BE49-F238E27FC236}">
-                <a16:creationId xmlns:a16="http://schemas.microsoft.com/office/drawing/2014/main" id="{FC3A2954-9920-4096-8475-AABA6C2C3833}"/>
+                <a16:creationId xmlns:a16="http://schemas.microsoft.com/office/drawing/2014/main" id="{402767B0-9FFF-4422-A227-A297136FB9DF}"/>
               </a:ext>
             </a:extLst>
           </p:cNvPr>
@@ -8956,7 +8956,7 @@
                 <a:ea typeface="Arial"/>
                 <a:cs typeface="Arial"/>
               </a:rPr>
-              <a:t>FORMULABENCH  ·  RESEARCH / TRACK 2</a:t>
+              <a:t>FORMULABENCH  ·  RESEARCH: EXCEL FORMULA GENERATION</a:t>
             </a:r>
           </a:p>
         </p:txBody>
@@ -8966,7 +8966,7 @@
           <p:cNvPr id="11" name="">
             <a:extLst xmlns:a="http://schemas.openxmlformats.org/drawingml/2006/main">
               <a:ext uri="{FF2B5EF4-FFF2-40B4-BE49-F238E27FC236}">
-                <a16:creationId xmlns:a16="http://schemas.microsoft.com/office/drawing/2014/main" id="{E687D580-2801-43EE-8CA5-B529A61982EC}"/>
+                <a16:creationId xmlns:a16="http://schemas.microsoft.com/office/drawing/2014/main" id="{E7CE1994-53C0-46EE-A963-379B83991A12}"/>
               </a:ext>
             </a:extLst>
           </p:cNvPr>
@@ -9025,7 +9025,7 @@
     </p:spTree>
     <p:extLst>
       <p:ext uri="{BB962C8B-B14F-4D97-AF65-F5344CB8AC3E}">
-        <p14:creationId xmlns:p14="http://schemas.microsoft.com/office/powerpoint/2010/main" val="711276457"/>
+        <p14:creationId xmlns:p14="http://schemas.microsoft.com/office/powerpoint/2010/main" val="354737023"/>
       </p:ext>
     </p:extLst>
   </p:cSld>
@@ -9056,7 +9056,7 @@
           <p:cNvPr id="19" name="slide-title">
             <a:extLst xmlns:a="http://schemas.openxmlformats.org/drawingml/2006/main">
               <a:ext uri="{FF2B5EF4-FFF2-40B4-BE49-F238E27FC236}">
-                <a16:creationId xmlns:a16="http://schemas.microsoft.com/office/drawing/2014/main" id="{8F379733-936C-4C7A-B21E-0F7E09899666}"/>
+                <a16:creationId xmlns:a16="http://schemas.microsoft.com/office/drawing/2014/main" id="{B85F2B5B-2F92-444C-9059-DD30139634C1}"/>
               </a:ext>
             </a:extLst>
           </p:cNvPr>
@@ -9117,7 +9117,7 @@
           <p:cNvPr id="2" name="">
             <a:extLst xmlns:a="http://schemas.openxmlformats.org/drawingml/2006/main">
               <a:ext uri="{FF2B5EF4-FFF2-40B4-BE49-F238E27FC236}">
-                <a16:creationId xmlns:a16="http://schemas.microsoft.com/office/drawing/2014/main" id="{030F87F3-D799-4653-BBA6-5B8FBC642992}"/>
+                <a16:creationId xmlns:a16="http://schemas.microsoft.com/office/drawing/2014/main" id="{A1B9B555-8C3B-40B2-AFC8-BB74EBB127F6}"/>
               </a:ext>
             </a:extLst>
           </p:cNvPr>
@@ -9178,7 +9178,7 @@
           <p:cNvPr id="3" name="">
             <a:extLst xmlns:a="http://schemas.openxmlformats.org/drawingml/2006/main">
               <a:ext uri="{FF2B5EF4-FFF2-40B4-BE49-F238E27FC236}">
-                <a16:creationId xmlns:a16="http://schemas.microsoft.com/office/drawing/2014/main" id="{F49B6104-A240-41A3-BCE3-AA5E0AB1F0A4}"/>
+                <a16:creationId xmlns:a16="http://schemas.microsoft.com/office/drawing/2014/main" id="{5D52CE17-52EF-4F05-A714-1DC55B7B2D80}"/>
               </a:ext>
             </a:extLst>
           </p:cNvPr>
@@ -9239,7 +9239,7 @@
           <p:cNvPr id="4" name="">
             <a:extLst xmlns:a="http://schemas.openxmlformats.org/drawingml/2006/main">
               <a:ext uri="{FF2B5EF4-FFF2-40B4-BE49-F238E27FC236}">
-                <a16:creationId xmlns:a16="http://schemas.microsoft.com/office/drawing/2014/main" id="{F2E19647-36B0-4F81-8918-8339A756DC80}"/>
+                <a16:creationId xmlns:a16="http://schemas.microsoft.com/office/drawing/2014/main" id="{1412B786-E45E-435A-B244-1BB31E44AAF8}"/>
               </a:ext>
             </a:extLst>
           </p:cNvPr>
@@ -9300,7 +9300,7 @@
           <p:cNvPr id="5" name="">
             <a:extLst xmlns:a="http://schemas.openxmlformats.org/drawingml/2006/main">
               <a:ext uri="{FF2B5EF4-FFF2-40B4-BE49-F238E27FC236}">
-                <a16:creationId xmlns:a16="http://schemas.microsoft.com/office/drawing/2014/main" id="{E3B93FE1-1945-44E5-8931-0B83E9D50D23}"/>
+                <a16:creationId xmlns:a16="http://schemas.microsoft.com/office/drawing/2014/main" id="{DC6F234E-086B-4E8C-A5FC-3A6C46BBF626}"/>
               </a:ext>
             </a:extLst>
           </p:cNvPr>
@@ -9361,7 +9361,7 @@
           <p:cNvPr id="6" name="">
             <a:extLst xmlns:a="http://schemas.openxmlformats.org/drawingml/2006/main">
               <a:ext uri="{FF2B5EF4-FFF2-40B4-BE49-F238E27FC236}">
-                <a16:creationId xmlns:a16="http://schemas.microsoft.com/office/drawing/2014/main" id="{059D2ACE-591E-481D-84E3-5651E4356D31}"/>
+                <a16:creationId xmlns:a16="http://schemas.microsoft.com/office/drawing/2014/main" id="{A0EB96B4-7D0A-4B4A-89AE-A2EFAA74A3E7}"/>
               </a:ext>
             </a:extLst>
           </p:cNvPr>
@@ -9422,7 +9422,7 @@
           <p:cNvPr id="7" name="">
             <a:extLst xmlns:a="http://schemas.openxmlformats.org/drawingml/2006/main">
               <a:ext uri="{FF2B5EF4-FFF2-40B4-BE49-F238E27FC236}">
-                <a16:creationId xmlns:a16="http://schemas.microsoft.com/office/drawing/2014/main" id="{C70D5C2F-3F89-46BB-9D6E-955EA5AC81E9}"/>
+                <a16:creationId xmlns:a16="http://schemas.microsoft.com/office/drawing/2014/main" id="{19454D9E-0F26-48E2-B297-692A646E4951}"/>
               </a:ext>
             </a:extLst>
           </p:cNvPr>
@@ -9483,7 +9483,7 @@
           <p:cNvPr id="8" name="">
             <a:extLst xmlns:a="http://schemas.openxmlformats.org/drawingml/2006/main">
               <a:ext uri="{FF2B5EF4-FFF2-40B4-BE49-F238E27FC236}">
-                <a16:creationId xmlns:a16="http://schemas.microsoft.com/office/drawing/2014/main" id="{0051F5E8-BF56-424D-8354-EAB1697B7E4B}"/>
+                <a16:creationId xmlns:a16="http://schemas.microsoft.com/office/drawing/2014/main" id="{AF69C495-F4E2-4C48-99B2-ECB3A19938A0}"/>
               </a:ext>
             </a:extLst>
           </p:cNvPr>
@@ -9544,7 +9544,7 @@
           <p:cNvPr id="9" name="">
             <a:extLst xmlns:a="http://schemas.openxmlformats.org/drawingml/2006/main">
               <a:ext uri="{FF2B5EF4-FFF2-40B4-BE49-F238E27FC236}">
-                <a16:creationId xmlns:a16="http://schemas.microsoft.com/office/drawing/2014/main" id="{20E36F81-BCFF-4112-B514-BB775E37D4F2}"/>
+                <a16:creationId xmlns:a16="http://schemas.microsoft.com/office/drawing/2014/main" id="{FA6A3CD3-9B02-4B97-B286-6B94626DB036}"/>
               </a:ext>
             </a:extLst>
           </p:cNvPr>
@@ -9575,7 +9575,7 @@
           <p:cNvPr id="10" name="">
             <a:extLst xmlns:a="http://schemas.openxmlformats.org/drawingml/2006/main">
               <a:ext uri="{FF2B5EF4-FFF2-40B4-BE49-F238E27FC236}">
-                <a16:creationId xmlns:a16="http://schemas.microsoft.com/office/drawing/2014/main" id="{2DF08957-8803-4C9B-8899-C74AC72A3157}"/>
+                <a16:creationId xmlns:a16="http://schemas.microsoft.com/office/drawing/2014/main" id="{CB851B38-55DE-469A-BB1C-F3A6B1B6C832}"/>
               </a:ext>
             </a:extLst>
           </p:cNvPr>
@@ -9608,7 +9608,7 @@
           <p:cNvPr id="11" name="">
             <a:extLst xmlns:a="http://schemas.openxmlformats.org/drawingml/2006/main">
               <a:ext uri="{FF2B5EF4-FFF2-40B4-BE49-F238E27FC236}">
-                <a16:creationId xmlns:a16="http://schemas.microsoft.com/office/drawing/2014/main" id="{EA7807D1-FAAF-4CB6-BE5E-DCFD07414099}"/>
+                <a16:creationId xmlns:a16="http://schemas.microsoft.com/office/drawing/2014/main" id="{BD8D9F8C-5547-4FB6-8A0E-E03F45C8E7F1}"/>
               </a:ext>
             </a:extLst>
           </p:cNvPr>
@@ -9669,7 +9669,7 @@
           <p:cNvPr id="12" name="">
             <a:extLst xmlns:a="http://schemas.openxmlformats.org/drawingml/2006/main">
               <a:ext uri="{FF2B5EF4-FFF2-40B4-BE49-F238E27FC236}">
-                <a16:creationId xmlns:a16="http://schemas.microsoft.com/office/drawing/2014/main" id="{7D77B95C-22FC-487B-8029-11F0B78C8CEE}"/>
+                <a16:creationId xmlns:a16="http://schemas.microsoft.com/office/drawing/2014/main" id="{8A78137C-4D72-453E-A4DB-1A1B189F36D9}"/>
               </a:ext>
             </a:extLst>
           </p:cNvPr>
@@ -9719,7 +9719,7 @@
                 <a:latin typeface="Arial"/>
                 <a:ea typeface="Arial"/>
                 <a:cs typeface="Arial"/>
-                <a:hlinkClick xmlns:r="http://schemas.openxmlformats.org/officeDocument/2006/relationships" r:id="R5e29216e7cd24a5e"/>
+                <a:hlinkClick xmlns:r="http://schemas.openxmlformats.org/officeDocument/2006/relationships" r:id="R5577c945197f498f"/>
               </a:rPr>
               <a:t>masterasnackin.github.io/FormulaBench/</a:t>
             </a:r>
@@ -9731,7 +9731,7 @@
           <p:cNvPr id="13" name="">
             <a:extLst xmlns:a="http://schemas.openxmlformats.org/drawingml/2006/main">
               <a:ext uri="{FF2B5EF4-FFF2-40B4-BE49-F238E27FC236}">
-                <a16:creationId xmlns:a16="http://schemas.microsoft.com/office/drawing/2014/main" id="{FADD9EE3-DD2C-4BD7-B95A-FA90A8ADE9F5}"/>
+                <a16:creationId xmlns:a16="http://schemas.microsoft.com/office/drawing/2014/main" id="{2045F149-FA9A-4396-B4C6-9EE3D9D6E718}"/>
               </a:ext>
             </a:extLst>
           </p:cNvPr>
@@ -9792,7 +9792,7 @@
           <p:cNvPr id="14" name="">
             <a:extLst xmlns:a="http://schemas.openxmlformats.org/drawingml/2006/main">
               <a:ext uri="{FF2B5EF4-FFF2-40B4-BE49-F238E27FC236}">
-                <a16:creationId xmlns:a16="http://schemas.microsoft.com/office/drawing/2014/main" id="{ADC0AD02-F850-4C95-A5F3-FC47A8C5BD58}"/>
+                <a16:creationId xmlns:a16="http://schemas.microsoft.com/office/drawing/2014/main" id="{01BE25ED-5DCD-40C0-A36B-C0AB99FED33A}"/>
               </a:ext>
             </a:extLst>
           </p:cNvPr>
@@ -9842,7 +9842,7 @@
                 <a:latin typeface="Arial"/>
                 <a:ea typeface="Arial"/>
                 <a:cs typeface="Arial"/>
-                <a:hlinkClick xmlns:r="http://schemas.openxmlformats.org/officeDocument/2006/relationships" r:id="Redafb4700ee547f3"/>
+                <a:hlinkClick xmlns:r="http://schemas.openxmlformats.org/officeDocument/2006/relationships" r:id="R59c6d52320114778"/>
               </a:rPr>
               <a:t>github.com/MasteraSnackin/FormulaBench</a:t>
             </a:r>
@@ -9854,7 +9854,7 @@
           <p:cNvPr id="15" name="">
             <a:extLst xmlns:a="http://schemas.openxmlformats.org/drawingml/2006/main">
               <a:ext uri="{FF2B5EF4-FFF2-40B4-BE49-F238E27FC236}">
-                <a16:creationId xmlns:a16="http://schemas.microsoft.com/office/drawing/2014/main" id="{4C7A43E5-DFDC-4CEC-B65E-BF2F327C5A32}"/>
+                <a16:creationId xmlns:a16="http://schemas.microsoft.com/office/drawing/2014/main" id="{EEB8171D-727A-435E-9B77-B44B5E700A22}"/>
               </a:ext>
             </a:extLst>
           </p:cNvPr>
@@ -9915,7 +9915,7 @@
           <p:cNvPr id="16" name="">
             <a:extLst xmlns:a="http://schemas.openxmlformats.org/drawingml/2006/main">
               <a:ext uri="{FF2B5EF4-FFF2-40B4-BE49-F238E27FC236}">
-                <a16:creationId xmlns:a16="http://schemas.microsoft.com/office/drawing/2014/main" id="{6FBE43A1-0EF5-48CB-AF53-B2F10700A415}"/>
+                <a16:creationId xmlns:a16="http://schemas.microsoft.com/office/drawing/2014/main" id="{860CDF5C-FAB4-4570-AC7A-239ABCAA7514}"/>
               </a:ext>
             </a:extLst>
           </p:cNvPr>
@@ -9946,7 +9946,7 @@
           <p:cNvPr id="17" name="">
             <a:extLst xmlns:a="http://schemas.openxmlformats.org/drawingml/2006/main">
               <a:ext uri="{FF2B5EF4-FFF2-40B4-BE49-F238E27FC236}">
-                <a16:creationId xmlns:a16="http://schemas.microsoft.com/office/drawing/2014/main" id="{B650E814-66AE-4CBD-980C-73FF1339D4F4}"/>
+                <a16:creationId xmlns:a16="http://schemas.microsoft.com/office/drawing/2014/main" id="{7411D65B-2D1B-42DC-BEFB-DABDC02F01F5}"/>
               </a:ext>
             </a:extLst>
           </p:cNvPr>
@@ -9997,7 +9997,7 @@
                 <a:ea typeface="Arial"/>
                 <a:cs typeface="Arial"/>
               </a:rPr>
-              <a:t>FORMULABENCH  ·  RESEARCH / TRACK 2</a:t>
+              <a:t>FORMULABENCH  ·  RESEARCH: EXCEL FORMULA GENERATION</a:t>
             </a:r>
           </a:p>
         </p:txBody>
@@ -10007,7 +10007,7 @@
           <p:cNvPr id="18" name="">
             <a:extLst xmlns:a="http://schemas.openxmlformats.org/drawingml/2006/main">
               <a:ext uri="{FF2B5EF4-FFF2-40B4-BE49-F238E27FC236}">
-                <a16:creationId xmlns:a16="http://schemas.microsoft.com/office/drawing/2014/main" id="{70078E2A-1CFF-491E-BEEE-D7C1C9241062}"/>
+                <a16:creationId xmlns:a16="http://schemas.microsoft.com/office/drawing/2014/main" id="{AE48A1B2-6F53-46C6-9931-A1792C35A024}"/>
               </a:ext>
             </a:extLst>
           </p:cNvPr>
@@ -10066,7 +10066,7 @@
     </p:spTree>
     <p:extLst>
       <p:ext uri="{BB962C8B-B14F-4D97-AF65-F5344CB8AC3E}">
-        <p14:creationId xmlns:p14="http://schemas.microsoft.com/office/powerpoint/2010/main" val="1142395564"/>
+        <p14:creationId xmlns:p14="http://schemas.microsoft.com/office/powerpoint/2010/main" val="364689557"/>
       </p:ext>
     </p:extLst>
   </p:cSld>

</xml_diff>